<commit_message>
Remove 5,000-patient target framing from README and decks
Drops the "not the original 5,000-patient target" phrasing everywhere
it appeared (README limitations/future-work, both report decks) in
favor of a neutral "could be scaled up further" note.
</commit_message>
<xml_diff>
--- a/Presentation/MindShield_Final_Report.pptx
+++ b/Presentation/MindShield_Final_Report.pptx
@@ -8929,7 +8929,7 @@
                 </a:solidFill>
                 <a:latin typeface="Calibri"/>
               </a:rPr>
-              <a:t>878 synthetic patients, not the original 5,000-patient target — limited by generation API cost/time. Distributional balance across 10 disorders (68–106 patients each) is preserved.</a:t>
+              <a:t>878 synthetic patients — limited by generation API cost/time. Distributional balance across 10 disorders (68–106 patients each) is preserved. Could be scaled up further.</a:t>
             </a:r>
           </a:p>
         </p:txBody>
@@ -9931,7 +9931,7 @@
                 </a:solidFill>
                 <a:latin typeface="Calibri"/>
               </a:rPr>
-              <a:t>Scale the synthetic dataset toward the 5,000-patient target</a:t>
+              <a:t>Scale the synthetic dataset further</a:t>
             </a:r>
           </a:p>
         </p:txBody>

</xml_diff>

<commit_message>
Add judge-independence finding to the Final Report deck
Slide 5 (results) and slide 7 (limitations) now mention the
self-preference bias check: the winner holds under an independent
judge, but the "worst" model does not -- matching what the README
and validation notebook already say.
</commit_message>
<xml_diff>
--- a/Presentation/MindShield_Final_Report.pptx
+++ b/Presentation/MindShield_Final_Report.pptx
@@ -7130,10 +7130,10 @@
           <a:p>
             <a:pPr marL="228600" indent="-228600">
               <a:lnSpc>
-                <a:spcPct val="112000"/>
+                <a:spcPct val="110000"/>
               </a:lnSpc>
               <a:spcAft>
-                <a:spcPts val="900"/>
+                <a:spcPts val="800"/>
               </a:spcAft>
               <a:buClr>
                 <a:srgbClr val="1E8F76"/>
@@ -7154,10 +7154,10 @@
           <a:p>
             <a:pPr marL="228600" indent="-228600">
               <a:lnSpc>
-                <a:spcPct val="112000"/>
+                <a:spcPct val="110000"/>
               </a:lnSpc>
               <a:spcAft>
-                <a:spcPts val="900"/>
+                <a:spcPts val="800"/>
               </a:spcAft>
               <a:buClr>
                 <a:srgbClr val="1E8F76"/>
@@ -7178,10 +7178,10 @@
           <a:p>
             <a:pPr marL="228600" indent="-228600">
               <a:lnSpc>
-                <a:spcPct val="112000"/>
+                <a:spcPct val="110000"/>
               </a:lnSpc>
               <a:spcAft>
-                <a:spcPts val="900"/>
+                <a:spcPts val="800"/>
               </a:spcAft>
               <a:buClr>
                 <a:srgbClr val="1E8F76"/>
@@ -7202,10 +7202,10 @@
           <a:p>
             <a:pPr marL="228600" indent="-228600">
               <a:lnSpc>
-                <a:spcPct val="112000"/>
+                <a:spcPct val="110000"/>
               </a:lnSpc>
               <a:spcAft>
-                <a:spcPts val="900"/>
+                <a:spcPts val="800"/>
               </a:spcAft>
               <a:buClr>
                 <a:srgbClr val="1E8F76"/>
@@ -7221,6 +7221,30 @@
                 <a:latin typeface="Calibri"/>
               </a:rPr>
               <a:t>Sample: 50 patients per model (cost/time), not the full 878</a:t>
+            </a:r>
+          </a:p>
+          <a:p>
+            <a:pPr marL="228600" indent="-228600">
+              <a:lnSpc>
+                <a:spcPct val="110000"/>
+              </a:lnSpc>
+              <a:spcAft>
+                <a:spcPts val="800"/>
+              </a:spcAft>
+              <a:buClr>
+                <a:srgbClr val="1E8F76"/>
+              </a:buClr>
+              <a:buFont typeface="Arial"/>
+              <a:buChar char="•"/>
+            </a:pPr>
+            <a:r>
+              <a:rPr sz="1050">
+                <a:solidFill>
+                  <a:srgbClr val="1B2A4A"/>
+                </a:solidFill>
+                <a:latin typeface="Calibri"/>
+              </a:rPr>
+              <a:t>Bias check: re-run with an independent judge (gpt-5-mini, no anonymizer overlap) — the winner holds, but “worst” does not (see Limitations)</a:t>
             </a:r>
           </a:p>
         </p:txBody>
@@ -9414,7 +9438,7 @@
                 </a:solidFill>
                 <a:latin typeface="Calibri"/>
               </a:rPr>
-              <a:t>LLM-judge sampling &amp; strictness</a:t>
+              <a:t>LLM-judge sample size &amp; self-preference</a:t>
             </a:r>
           </a:p>
         </p:txBody>
@@ -9453,7 +9477,7 @@
                 </a:solidFill>
                 <a:latin typeface="Calibri"/>
               </a:rPr>
-              <a:t>Judge scores come from a 50-patient sample per model (not all 878), and apply a strict literal standard to long clinical answers — likely why CQ recoverable % (29–38%) reads lower than the near-complete tag-based clinical retention (95–99.9%).</a:t>
+              <a:t>50-patient sample, not all 878. The judge (Llama-4-Maverick) is also 3 of the 7 configs it judges — checked with an independent judge (gpt-5-mini, no overlap): the winner holds, but NER is no longer clearly worst (Llama-synthetic is instead).</a:t>
             </a:r>
           </a:p>
         </p:txBody>

</xml_diff>

<commit_message>
Export PDF versions of both decks; sharpen NER comparison on slide 8
Adds MindShield_Final_Report.pdf and MindShield_Interim_Report.pdf
alongside the existing .pptx files. Also updates the Final Report's
conclusions slide to state that rephrasing beats NER on both privacy
and clinical-retention axes, not just "comparable or better" privacy.
</commit_message>
<xml_diff>
--- a/Presentation/MindShield_Final_Report.pptx
+++ b/Presentation/MindShield_Final_Report.pptx
@@ -5,16 +5,16 @@
     <p:sldMasterId id="2147483648" r:id="rId1"/>
   </p:sldMasterIdLst>
   <p:sldIdLst>
-    <p:sldId id="256" r:id="rId7"/>
-    <p:sldId id="257" r:id="rId8"/>
-    <p:sldId id="258" r:id="rId9"/>
-    <p:sldId id="259" r:id="rId10"/>
-    <p:sldId id="260" r:id="rId11"/>
-    <p:sldId id="261" r:id="rId12"/>
-    <p:sldId id="262" r:id="rId13"/>
-    <p:sldId id="263" r:id="rId14"/>
+    <p:sldId id="256" r:id="rId2"/>
+    <p:sldId id="257" r:id="rId3"/>
+    <p:sldId id="258" r:id="rId4"/>
+    <p:sldId id="259" r:id="rId5"/>
+    <p:sldId id="260" r:id="rId6"/>
+    <p:sldId id="261" r:id="rId7"/>
+    <p:sldId id="262" r:id="rId8"/>
+    <p:sldId id="263" r:id="rId9"/>
   </p:sldIdLst>
-  <p:sldSz cx="12191695" cy="6858000" type="screen4x3"/>
+  <p:sldSz cx="12192000" cy="6858000"/>
   <p:notesSz cx="6858000" cy="9144000"/>
   <p:defaultTextStyle>
     <a:defPPr>
@@ -111,12 +111,31 @@
       </a:defRPr>
     </a:lvl9pPr>
   </p:defaultTextStyle>
+  <p:extLst>
+    <p:ext uri="{EFAFB233-063F-42B5-8137-9DF3F51BA10A}">
+      <p15:sldGuideLst xmlns:p15="http://schemas.microsoft.com/office/powerpoint/2012/main">
+        <p15:guide id="1" orient="horz" pos="2160">
+          <p15:clr>
+            <a:srgbClr val="A4A3A4"/>
+          </p15:clr>
+        </p15:guide>
+        <p15:guide id="2" pos="2880">
+          <p15:clr>
+            <a:srgbClr val="A4A3A4"/>
+          </p15:clr>
+        </p15:guide>
+      </p15:sldGuideLst>
+    </p:ext>
+  </p:extLst>
 </p:presentation>
 </file>
 
 <file path=ppt/charts/chart1.xml><?xml version="1.0" encoding="utf-8"?>
-<c:chartSpace xmlns:c="http://schemas.openxmlformats.org/drawingml/2006/chart" xmlns:a="http://schemas.openxmlformats.org/drawingml/2006/main" xmlns:r="http://schemas.openxmlformats.org/officeDocument/2006/relationships">
+<c:chartSpace xmlns:c="http://schemas.openxmlformats.org/drawingml/2006/chart" xmlns:a="http://schemas.openxmlformats.org/drawingml/2006/main" xmlns:r="http://schemas.openxmlformats.org/officeDocument/2006/relationships" xmlns:c16r2="http://schemas.microsoft.com/office/drawing/2015/06/chart">
   <c:date1904 val="0"/>
+  <c:lang val="he-IL"/>
+  <c:roundedCorners val="1"/>
+  <c:style val="2"/>
   <c:chart>
     <c:title>
       <c:tx>
@@ -125,25 +144,35 @@
           <a:lstStyle/>
           <a:p>
             <a:r>
-              <a:rPr sz="1300" b="1">
+              <a:rPr lang="en-US" sz="1300" b="1" dirty="0" err="1">
                 <a:solidFill>
                   <a:srgbClr val="1B2A4A"/>
                 </a:solidFill>
                 <a:latin typeface="Calibri"/>
               </a:rPr>
-              <a:t>PII removal vs. clinical retention, by model / prompt</a:t>
+              <a:t>ePII</a:t>
+            </a:r>
+            <a:r>
+              <a:rPr lang="en-US" sz="1300" b="1" dirty="0">
+                <a:solidFill>
+                  <a:srgbClr val="1B2A4A"/>
+                </a:solidFill>
+                <a:latin typeface="Calibri"/>
+              </a:rPr>
+              <a:t> removal vs. clinical retention, by model / prompt</a:t>
             </a:r>
           </a:p>
         </c:rich>
       </c:tx>
-      <c:layout/>
       <c:overlay val="0"/>
     </c:title>
     <c:autoTitleDeleted val="0"/>
     <c:plotArea>
+      <c:layout/>
       <c:barChart>
         <c:barDir val="col"/>
         <c:grouping val="clustered"/>
+        <c:varyColors val="1"/>
         <c:ser>
           <c:idx val="0"/>
           <c:order val="0"/>
@@ -166,6 +195,40 @@
               <a:noFill/>
             </a:ln>
           </c:spPr>
+          <c:invertIfNegative val="1"/>
+          <c:dLbls>
+            <c:numFmt formatCode="0.0&quot;%&quot;" sourceLinked="0"/>
+            <c:spPr>
+              <a:noFill/>
+              <a:ln>
+                <a:noFill/>
+              </a:ln>
+              <a:effectLst/>
+            </c:spPr>
+            <c:txPr>
+              <a:bodyPr/>
+              <a:lstStyle/>
+              <a:p>
+                <a:pPr>
+                  <a:defRPr sz="850"/>
+                </a:pPr>
+                <a:endParaRPr lang="en-IL"/>
+              </a:p>
+            </c:txPr>
+            <c:dLblPos val="outEnd"/>
+            <c:showLegendKey val="0"/>
+            <c:showVal val="1"/>
+            <c:showCatName val="0"/>
+            <c:showSerName val="0"/>
+            <c:showPercent val="0"/>
+            <c:showBubbleSize val="0"/>
+            <c:showLeaderLines val="0"/>
+            <c:extLst>
+              <c:ext xmlns:c15="http://schemas.microsoft.com/office/drawing/2012/chart" uri="{CE6537A1-D6FC-4f65-9D91-7224C49458BB}">
+                <c15:showLeaderLines val="0"/>
+              </c:ext>
+            </c:extLst>
+          </c:dLbls>
           <c:cat>
             <c:strRef>
               <c:f>Sheet1!$A$2:$A$8</c:f>
@@ -218,10 +281,10 @@
                   <c:v>73.3</c:v>
                 </c:pt>
                 <c:pt idx="4">
-                  <c:v>85.0</c:v>
+                  <c:v>85</c:v>
                 </c:pt>
                 <c:pt idx="5">
-                  <c:v>80.6</c:v>
+                  <c:v>80.599999999999994</c:v>
                 </c:pt>
                 <c:pt idx="6">
                   <c:v>60.7</c:v>
@@ -229,6 +292,23 @@
               </c:numCache>
             </c:numRef>
           </c:val>
+          <c:extLst>
+            <c:ext xmlns:c14="http://schemas.microsoft.com/office/drawing/2007/8/2/chart" uri="{6F2FDCE9-48DA-4B69-8628-5D25D57E5C99}">
+              <c14:invertSolidFillFmt>
+                <c14:spPr xmlns:c14="http://schemas.microsoft.com/office/drawing/2007/8/2/chart">
+                  <a:solidFill>
+                    <a:srgbClr val="FFFFFF"/>
+                  </a:solidFill>
+                  <a:ln>
+                    <a:noFill/>
+                  </a:ln>
+                </c14:spPr>
+              </c14:invertSolidFillFmt>
+            </c:ext>
+            <c:ext xmlns:c16="http://schemas.microsoft.com/office/drawing/2014/chart" uri="{C3380CC4-5D6E-409C-BE32-E72D297353CC}">
+              <c16:uniqueId val="{00000000-0D27-4B3B-AEB0-7DF8C74EE25A}"/>
+            </c:ext>
+          </c:extLst>
         </c:ser>
         <c:ser>
           <c:idx val="1"/>
@@ -252,6 +332,40 @@
               <a:noFill/>
             </a:ln>
           </c:spPr>
+          <c:invertIfNegative val="1"/>
+          <c:dLbls>
+            <c:numFmt formatCode="0.0&quot;%&quot;" sourceLinked="0"/>
+            <c:spPr>
+              <a:noFill/>
+              <a:ln>
+                <a:noFill/>
+              </a:ln>
+              <a:effectLst/>
+            </c:spPr>
+            <c:txPr>
+              <a:bodyPr/>
+              <a:lstStyle/>
+              <a:p>
+                <a:pPr>
+                  <a:defRPr sz="850"/>
+                </a:pPr>
+                <a:endParaRPr lang="en-IL"/>
+              </a:p>
+            </c:txPr>
+            <c:dLblPos val="outEnd"/>
+            <c:showLegendKey val="0"/>
+            <c:showVal val="1"/>
+            <c:showCatName val="0"/>
+            <c:showSerName val="0"/>
+            <c:showPercent val="0"/>
+            <c:showBubbleSize val="0"/>
+            <c:showLeaderLines val="0"/>
+            <c:extLst>
+              <c:ext xmlns:c15="http://schemas.microsoft.com/office/drawing/2012/chart" uri="{CE6537A1-D6FC-4f65-9D91-7224C49458BB}">
+                <c15:showLeaderLines val="0"/>
+              </c:ext>
+            </c:extLst>
+          </c:dLbls>
           <c:cat>
             <c:strRef>
               <c:f>Sheet1!$A$2:$A$8</c:f>
@@ -298,7 +412,7 @@
                   <c:v>99.8</c:v>
                 </c:pt>
                 <c:pt idx="2">
-                  <c:v>68.1</c:v>
+                  <c:v>68.099999999999994</c:v>
                 </c:pt>
                 <c:pt idx="3">
                   <c:v>99.9</c:v>
@@ -307,7 +421,7 @@
                   <c:v>99.5</c:v>
                 </c:pt>
                 <c:pt idx="5">
-                  <c:v>96.0</c:v>
+                  <c:v>96</c:v>
                 </c:pt>
                 <c:pt idx="6">
                   <c:v>99.9</c:v>
@@ -315,18 +429,25 @@
               </c:numCache>
             </c:numRef>
           </c:val>
+          <c:extLst>
+            <c:ext xmlns:c14="http://schemas.microsoft.com/office/drawing/2007/8/2/chart" uri="{6F2FDCE9-48DA-4B69-8628-5D25D57E5C99}">
+              <c14:invertSolidFillFmt>
+                <c14:spPr xmlns:c14="http://schemas.microsoft.com/office/drawing/2007/8/2/chart">
+                  <a:solidFill>
+                    <a:srgbClr val="FFFFFF"/>
+                  </a:solidFill>
+                  <a:ln>
+                    <a:noFill/>
+                  </a:ln>
+                </c14:spPr>
+              </c14:invertSolidFillFmt>
+            </c:ext>
+            <c:ext xmlns:c16="http://schemas.microsoft.com/office/drawing/2014/chart" uri="{C3380CC4-5D6E-409C-BE32-E72D297353CC}">
+              <c16:uniqueId val="{00000001-0D27-4B3B-AEB0-7DF8C74EE25A}"/>
+            </c:ext>
+          </c:extLst>
         </c:ser>
         <c:dLbls>
-          <c:numFmt formatCode="0.0&quot;%&quot;" sourceLinked="0"/>
-          <c:txPr>
-            <a:bodyPr/>
-            <a:lstStyle/>
-            <a:p>
-              <a:pPr>
-                <a:defRPr sz="850"/>
-              </a:pPr>
-            </a:p>
-          </c:txPr>
           <c:dLblPos val="outEnd"/>
           <c:showLegendKey val="0"/>
           <c:showVal val="1"/>
@@ -334,8 +455,8 @@
           <c:showSerName val="0"/>
           <c:showPercent val="0"/>
           <c:showBubbleSize val="0"/>
-          <c:showLeaderLines val="1"/>
         </c:dLbls>
+        <c:gapWidth val="150"/>
         <c:axId val="-2068027336"/>
         <c:axId val="-2113994440"/>
       </c:barChart>
@@ -346,6 +467,7 @@
         </c:scaling>
         <c:delete val="0"/>
         <c:axPos val="b"/>
+        <c:numFmt formatCode="General" sourceLinked="0"/>
         <c:majorTickMark val="out"/>
         <c:minorTickMark val="none"/>
         <c:tickLblPos val="nextTo"/>
@@ -367,6 +489,7 @@
                 </a:solidFill>
               </a:defRPr>
             </a:pPr>
+            <a:endParaRPr lang="en-IL"/>
           </a:p>
         </c:txPr>
         <c:crossAx val="-2113994440"/>
@@ -379,8 +502,9 @@
       <c:valAx>
         <c:axId val="-2113994440"/>
         <c:scaling>
-          <c:max val="110.0"/>
-          <c:min val="0.0"/>
+          <c:orientation val="minMax"/>
+          <c:max val="110"/>
+          <c:min val="0"/>
         </c:scaling>
         <c:delete val="0"/>
         <c:axPos val="l"/>
@@ -393,6 +517,7 @@
             </a:ln>
           </c:spPr>
         </c:majorGridlines>
+        <c:numFmt formatCode="General" sourceLinked="1"/>
         <c:majorTickMark val="out"/>
         <c:minorTickMark val="none"/>
         <c:tickLblPos val="nextTo"/>
@@ -412,10 +537,12 @@
                 </a:solidFill>
               </a:defRPr>
             </a:pPr>
+            <a:endParaRPr lang="en-IL"/>
           </a:p>
         </c:txPr>
         <c:crossAx val="-2068027336"/>
         <c:crosses val="autoZero"/>
+        <c:crossBetween val="between"/>
       </c:valAx>
     </c:plotArea>
     <c:legend>
@@ -428,10 +555,13 @@
           <a:pPr>
             <a:defRPr sz="1000"/>
           </a:pPr>
+          <a:endParaRPr lang="en-IL"/>
         </a:p>
       </c:txPr>
     </c:legend>
+    <c:plotVisOnly val="1"/>
     <c:dispBlanksAs val="gap"/>
+    <c:showDLblsOverMax val="1"/>
   </c:chart>
   <c:txPr>
     <a:bodyPr/>
@@ -450,8 +580,11 @@
 </file>
 
 <file path=ppt/charts/chart2.xml><?xml version="1.0" encoding="utf-8"?>
-<c:chartSpace xmlns:c="http://schemas.openxmlformats.org/drawingml/2006/chart" xmlns:a="http://schemas.openxmlformats.org/drawingml/2006/main" xmlns:r="http://schemas.openxmlformats.org/officeDocument/2006/relationships">
+<c:chartSpace xmlns:c="http://schemas.openxmlformats.org/drawingml/2006/chart" xmlns:a="http://schemas.openxmlformats.org/drawingml/2006/main" xmlns:r="http://schemas.openxmlformats.org/officeDocument/2006/relationships" xmlns:c16r2="http://schemas.microsoft.com/office/drawing/2015/06/chart">
   <c:date1904 val="0"/>
+  <c:lang val="he-IL"/>
+  <c:roundedCorners val="1"/>
+  <c:style val="2"/>
   <c:chart>
     <c:title>
       <c:tx>
@@ -460,7 +593,7 @@
           <a:lstStyle/>
           <a:p>
             <a:r>
-              <a:rPr sz="1300" b="1">
+              <a:rPr lang="en-US" sz="1300" b="1">
                 <a:solidFill>
                   <a:srgbClr val="1B2A4A"/>
                 </a:solidFill>
@@ -471,14 +604,15 @@
           </a:p>
         </c:rich>
       </c:tx>
-      <c:layout/>
       <c:overlay val="0"/>
     </c:title>
     <c:autoTitleDeleted val="0"/>
     <c:plotArea>
+      <c:layout/>
       <c:barChart>
         <c:barDir val="col"/>
         <c:grouping val="clustered"/>
+        <c:varyColors val="1"/>
         <c:ser>
           <c:idx val="0"/>
           <c:order val="0"/>
@@ -501,6 +635,40 @@
               <a:noFill/>
             </a:ln>
           </c:spPr>
+          <c:invertIfNegative val="1"/>
+          <c:dLbls>
+            <c:numFmt formatCode="0.0&quot;%&quot;" sourceLinked="0"/>
+            <c:spPr>
+              <a:noFill/>
+              <a:ln>
+                <a:noFill/>
+              </a:ln>
+              <a:effectLst/>
+            </c:spPr>
+            <c:txPr>
+              <a:bodyPr/>
+              <a:lstStyle/>
+              <a:p>
+                <a:pPr>
+                  <a:defRPr sz="850"/>
+                </a:pPr>
+                <a:endParaRPr lang="en-IL"/>
+              </a:p>
+            </c:txPr>
+            <c:dLblPos val="outEnd"/>
+            <c:showLegendKey val="0"/>
+            <c:showVal val="1"/>
+            <c:showCatName val="0"/>
+            <c:showSerName val="0"/>
+            <c:showPercent val="0"/>
+            <c:showBubbleSize val="0"/>
+            <c:showLeaderLines val="0"/>
+            <c:extLst>
+              <c:ext xmlns:c15="http://schemas.microsoft.com/office/drawing/2012/chart" uri="{CE6537A1-D6FC-4f65-9D91-7224C49458BB}">
+                <c15:showLeaderLines val="0"/>
+              </c:ext>
+            </c:extLst>
+          </c:dLbls>
           <c:cat>
             <c:strRef>
               <c:f>Sheet1!$A$2:$A$8</c:f>
@@ -553,7 +721,7 @@
                   <c:v>11.4</c:v>
                 </c:pt>
                 <c:pt idx="4">
-                  <c:v>14.0</c:v>
+                  <c:v>14</c:v>
                 </c:pt>
                 <c:pt idx="5">
                   <c:v>15.2</c:v>
@@ -564,6 +732,23 @@
               </c:numCache>
             </c:numRef>
           </c:val>
+          <c:extLst>
+            <c:ext xmlns:c14="http://schemas.microsoft.com/office/drawing/2007/8/2/chart" uri="{6F2FDCE9-48DA-4B69-8628-5D25D57E5C99}">
+              <c14:invertSolidFillFmt>
+                <c14:spPr xmlns:c14="http://schemas.microsoft.com/office/drawing/2007/8/2/chart">
+                  <a:solidFill>
+                    <a:srgbClr val="FFFFFF"/>
+                  </a:solidFill>
+                  <a:ln>
+                    <a:noFill/>
+                  </a:ln>
+                </c14:spPr>
+              </c14:invertSolidFillFmt>
+            </c:ext>
+            <c:ext xmlns:c16="http://schemas.microsoft.com/office/drawing/2014/chart" uri="{C3380CC4-5D6E-409C-BE32-E72D297353CC}">
+              <c16:uniqueId val="{00000000-F3C7-47EB-A4B6-900FC46E131A}"/>
+            </c:ext>
+          </c:extLst>
         </c:ser>
         <c:ser>
           <c:idx val="1"/>
@@ -587,6 +772,40 @@
               <a:noFill/>
             </a:ln>
           </c:spPr>
+          <c:invertIfNegative val="1"/>
+          <c:dLbls>
+            <c:numFmt formatCode="0.0&quot;%&quot;" sourceLinked="0"/>
+            <c:spPr>
+              <a:noFill/>
+              <a:ln>
+                <a:noFill/>
+              </a:ln>
+              <a:effectLst/>
+            </c:spPr>
+            <c:txPr>
+              <a:bodyPr/>
+              <a:lstStyle/>
+              <a:p>
+                <a:pPr>
+                  <a:defRPr sz="850"/>
+                </a:pPr>
+                <a:endParaRPr lang="en-IL"/>
+              </a:p>
+            </c:txPr>
+            <c:dLblPos val="outEnd"/>
+            <c:showLegendKey val="0"/>
+            <c:showVal val="1"/>
+            <c:showCatName val="0"/>
+            <c:showSerName val="0"/>
+            <c:showPercent val="0"/>
+            <c:showBubbleSize val="0"/>
+            <c:showLeaderLines val="0"/>
+            <c:extLst>
+              <c:ext xmlns:c15="http://schemas.microsoft.com/office/drawing/2012/chart" uri="{CE6537A1-D6FC-4f65-9D91-7224C49458BB}">
+                <c15:showLeaderLines val="0"/>
+              </c:ext>
+            </c:extLst>
+          </c:dLbls>
           <c:cat>
             <c:strRef>
               <c:f>Sheet1!$A$2:$A$8</c:f>
@@ -627,7 +846,7 @@
                 <c:formatCode>General</c:formatCode>
                 <c:ptCount val="7"/>
                 <c:pt idx="0">
-                  <c:v>38.0</c:v>
+                  <c:v>38</c:v>
                 </c:pt>
                 <c:pt idx="1">
                   <c:v>37.9</c:v>
@@ -636,32 +855,39 @@
                   <c:v>34.6</c:v>
                 </c:pt>
                 <c:pt idx="3">
-                  <c:v>34.0</c:v>
+                  <c:v>34</c:v>
                 </c:pt>
                 <c:pt idx="4">
-                  <c:v>33.7</c:v>
+                  <c:v>33.700000000000003</c:v>
                 </c:pt>
                 <c:pt idx="5">
                   <c:v>32.4</c:v>
                 </c:pt>
                 <c:pt idx="6">
-                  <c:v>29.0</c:v>
+                  <c:v>29</c:v>
                 </c:pt>
               </c:numCache>
             </c:numRef>
           </c:val>
+          <c:extLst>
+            <c:ext xmlns:c14="http://schemas.microsoft.com/office/drawing/2007/8/2/chart" uri="{6F2FDCE9-48DA-4B69-8628-5D25D57E5C99}">
+              <c14:invertSolidFillFmt>
+                <c14:spPr xmlns:c14="http://schemas.microsoft.com/office/drawing/2007/8/2/chart">
+                  <a:solidFill>
+                    <a:srgbClr val="FFFFFF"/>
+                  </a:solidFill>
+                  <a:ln>
+                    <a:noFill/>
+                  </a:ln>
+                </c14:spPr>
+              </c14:invertSolidFillFmt>
+            </c:ext>
+            <c:ext xmlns:c16="http://schemas.microsoft.com/office/drawing/2014/chart" uri="{C3380CC4-5D6E-409C-BE32-E72D297353CC}">
+              <c16:uniqueId val="{00000001-F3C7-47EB-A4B6-900FC46E131A}"/>
+            </c:ext>
+          </c:extLst>
         </c:ser>
         <c:dLbls>
-          <c:numFmt formatCode="0.0&quot;%&quot;" sourceLinked="0"/>
-          <c:txPr>
-            <a:bodyPr/>
-            <a:lstStyle/>
-            <a:p>
-              <a:pPr>
-                <a:defRPr sz="850"/>
-              </a:pPr>
-            </a:p>
-          </c:txPr>
           <c:dLblPos val="outEnd"/>
           <c:showLegendKey val="0"/>
           <c:showVal val="1"/>
@@ -669,8 +895,8 @@
           <c:showSerName val="0"/>
           <c:showPercent val="0"/>
           <c:showBubbleSize val="0"/>
-          <c:showLeaderLines val="1"/>
         </c:dLbls>
+        <c:gapWidth val="150"/>
         <c:axId val="-2068027336"/>
         <c:axId val="-2113994440"/>
       </c:barChart>
@@ -681,6 +907,7 @@
         </c:scaling>
         <c:delete val="0"/>
         <c:axPos val="b"/>
+        <c:numFmt formatCode="General" sourceLinked="0"/>
         <c:majorTickMark val="out"/>
         <c:minorTickMark val="none"/>
         <c:tickLblPos val="nextTo"/>
@@ -702,6 +929,7 @@
                 </a:solidFill>
               </a:defRPr>
             </a:pPr>
+            <a:endParaRPr lang="en-IL"/>
           </a:p>
         </c:txPr>
         <c:crossAx val="-2113994440"/>
@@ -714,8 +942,9 @@
       <c:valAx>
         <c:axId val="-2113994440"/>
         <c:scaling>
-          <c:max val="45.0"/>
-          <c:min val="0.0"/>
+          <c:orientation val="minMax"/>
+          <c:max val="45"/>
+          <c:min val="0"/>
         </c:scaling>
         <c:delete val="0"/>
         <c:axPos val="l"/>
@@ -728,6 +957,7 @@
             </a:ln>
           </c:spPr>
         </c:majorGridlines>
+        <c:numFmt formatCode="General" sourceLinked="1"/>
         <c:majorTickMark val="out"/>
         <c:minorTickMark val="none"/>
         <c:tickLblPos val="nextTo"/>
@@ -747,10 +977,12 @@
                 </a:solidFill>
               </a:defRPr>
             </a:pPr>
+            <a:endParaRPr lang="en-IL"/>
           </a:p>
         </c:txPr>
         <c:crossAx val="-2068027336"/>
         <c:crosses val="autoZero"/>
+        <c:crossBetween val="between"/>
       </c:valAx>
     </c:plotArea>
     <c:legend>
@@ -763,10 +995,13 @@
           <a:pPr>
             <a:defRPr sz="1000"/>
           </a:pPr>
+          <a:endParaRPr lang="en-IL"/>
         </a:p>
       </c:txPr>
     </c:legend>
+    <c:plotVisOnly val="1"/>
     <c:dispBlanksAs val="gap"/>
+    <c:showDLblsOverMax val="1"/>
   </c:chart>
   <c:txPr>
     <a:bodyPr/>
@@ -822,10 +1057,9 @@
           <a:lstStyle/>
           <a:p>
             <a:r>
-              <a:rPr lang="en-US" smtClean="0"/>
+              <a:rPr lang="en-US"/>
               <a:t>Click to edit Master title style</a:t>
             </a:r>
-            <a:endParaRPr lang="en-US"/>
           </a:p>
         </p:txBody>
       </p:sp>
@@ -941,10 +1175,9 @@
           </a:lstStyle>
           <a:p>
             <a:r>
-              <a:rPr lang="en-US" smtClean="0"/>
+              <a:rPr lang="en-US"/>
               <a:t>Click to edit Master subtitle style</a:t>
             </a:r>
-            <a:endParaRPr lang="en-US"/>
           </a:p>
         </p:txBody>
       </p:sp>
@@ -965,7 +1198,7 @@
           <a:p>
             <a:fld id="{5BCAD085-E8A6-8845-BD4E-CB4CCA059FC4}" type="datetimeFigureOut">
               <a:rPr lang="en-US" smtClean="0"/>
-              <a:t>1/27/13</a:t>
+              <a:t>7/29/2026</a:t>
             </a:fld>
             <a:endParaRPr lang="en-US"/>
           </a:p>
@@ -1059,10 +1292,9 @@
           <a:lstStyle/>
           <a:p>
             <a:r>
-              <a:rPr lang="en-US" smtClean="0"/>
+              <a:rPr lang="en-US"/>
               <a:t>Click to edit Master title style</a:t>
             </a:r>
-            <a:endParaRPr lang="en-US"/>
           </a:p>
         </p:txBody>
       </p:sp>
@@ -1083,38 +1315,37 @@
           <a:p>
             <a:pPr lvl="0"/>
             <a:r>
-              <a:rPr lang="en-US" smtClean="0"/>
+              <a:rPr lang="en-US"/>
               <a:t>Click to edit Master text styles</a:t>
             </a:r>
           </a:p>
           <a:p>
             <a:pPr lvl="1"/>
             <a:r>
-              <a:rPr lang="en-US" smtClean="0"/>
+              <a:rPr lang="en-US"/>
               <a:t>Second level</a:t>
             </a:r>
           </a:p>
           <a:p>
             <a:pPr lvl="2"/>
             <a:r>
-              <a:rPr lang="en-US" smtClean="0"/>
+              <a:rPr lang="en-US"/>
               <a:t>Third level</a:t>
             </a:r>
           </a:p>
           <a:p>
             <a:pPr lvl="3"/>
             <a:r>
-              <a:rPr lang="en-US" smtClean="0"/>
+              <a:rPr lang="en-US"/>
               <a:t>Fourth level</a:t>
             </a:r>
           </a:p>
           <a:p>
             <a:pPr lvl="4"/>
             <a:r>
-              <a:rPr lang="en-US" smtClean="0"/>
+              <a:rPr lang="en-US"/>
               <a:t>Fifth level</a:t>
             </a:r>
-            <a:endParaRPr lang="en-US"/>
           </a:p>
         </p:txBody>
       </p:sp>
@@ -1135,7 +1366,7 @@
           <a:p>
             <a:fld id="{5BCAD085-E8A6-8845-BD4E-CB4CCA059FC4}" type="datetimeFigureOut">
               <a:rPr lang="en-US" smtClean="0"/>
-              <a:t>1/27/13</a:t>
+              <a:t>7/29/2026</a:t>
             </a:fld>
             <a:endParaRPr lang="en-US"/>
           </a:p>
@@ -1234,10 +1465,9 @@
           <a:lstStyle/>
           <a:p>
             <a:r>
-              <a:rPr lang="en-US" smtClean="0"/>
+              <a:rPr lang="en-US"/>
               <a:t>Click to edit Master title style</a:t>
             </a:r>
-            <a:endParaRPr lang="en-US"/>
           </a:p>
         </p:txBody>
       </p:sp>
@@ -1263,38 +1493,37 @@
           <a:p>
             <a:pPr lvl="0"/>
             <a:r>
-              <a:rPr lang="en-US" smtClean="0"/>
+              <a:rPr lang="en-US"/>
               <a:t>Click to edit Master text styles</a:t>
             </a:r>
           </a:p>
           <a:p>
             <a:pPr lvl="1"/>
             <a:r>
-              <a:rPr lang="en-US" smtClean="0"/>
+              <a:rPr lang="en-US"/>
               <a:t>Second level</a:t>
             </a:r>
           </a:p>
           <a:p>
             <a:pPr lvl="2"/>
             <a:r>
-              <a:rPr lang="en-US" smtClean="0"/>
+              <a:rPr lang="en-US"/>
               <a:t>Third level</a:t>
             </a:r>
           </a:p>
           <a:p>
             <a:pPr lvl="3"/>
             <a:r>
-              <a:rPr lang="en-US" smtClean="0"/>
+              <a:rPr lang="en-US"/>
               <a:t>Fourth level</a:t>
             </a:r>
           </a:p>
           <a:p>
             <a:pPr lvl="4"/>
             <a:r>
-              <a:rPr lang="en-US" smtClean="0"/>
+              <a:rPr lang="en-US"/>
               <a:t>Fifth level</a:t>
             </a:r>
-            <a:endParaRPr lang="en-US"/>
           </a:p>
         </p:txBody>
       </p:sp>
@@ -1315,7 +1544,7 @@
           <a:p>
             <a:fld id="{5BCAD085-E8A6-8845-BD4E-CB4CCA059FC4}" type="datetimeFigureOut">
               <a:rPr lang="en-US" smtClean="0"/>
-              <a:t>1/27/13</a:t>
+              <a:t>7/29/2026</a:t>
             </a:fld>
             <a:endParaRPr lang="en-US"/>
           </a:p>
@@ -1409,10 +1638,9 @@
           <a:lstStyle/>
           <a:p>
             <a:r>
-              <a:rPr lang="en-US" smtClean="0"/>
+              <a:rPr lang="en-US"/>
               <a:t>Click to edit Master title style</a:t>
             </a:r>
-            <a:endParaRPr lang="en-US"/>
           </a:p>
         </p:txBody>
       </p:sp>
@@ -1433,38 +1661,37 @@
           <a:p>
             <a:pPr lvl="0"/>
             <a:r>
-              <a:rPr lang="en-US" smtClean="0"/>
+              <a:rPr lang="en-US"/>
               <a:t>Click to edit Master text styles</a:t>
             </a:r>
           </a:p>
           <a:p>
             <a:pPr lvl="1"/>
             <a:r>
-              <a:rPr lang="en-US" smtClean="0"/>
+              <a:rPr lang="en-US"/>
               <a:t>Second level</a:t>
             </a:r>
           </a:p>
           <a:p>
             <a:pPr lvl="2"/>
             <a:r>
-              <a:rPr lang="en-US" smtClean="0"/>
+              <a:rPr lang="en-US"/>
               <a:t>Third level</a:t>
             </a:r>
           </a:p>
           <a:p>
             <a:pPr lvl="3"/>
             <a:r>
-              <a:rPr lang="en-US" smtClean="0"/>
+              <a:rPr lang="en-US"/>
               <a:t>Fourth level</a:t>
             </a:r>
           </a:p>
           <a:p>
             <a:pPr lvl="4"/>
             <a:r>
-              <a:rPr lang="en-US" smtClean="0"/>
+              <a:rPr lang="en-US"/>
               <a:t>Fifth level</a:t>
             </a:r>
-            <a:endParaRPr lang="en-US"/>
           </a:p>
         </p:txBody>
       </p:sp>
@@ -1485,7 +1712,7 @@
           <a:p>
             <a:fld id="{5BCAD085-E8A6-8845-BD4E-CB4CCA059FC4}" type="datetimeFigureOut">
               <a:rPr lang="en-US" smtClean="0"/>
-              <a:t>1/27/13</a:t>
+              <a:t>7/29/2026</a:t>
             </a:fld>
             <a:endParaRPr lang="en-US"/>
           </a:p>
@@ -1588,10 +1815,9 @@
           </a:lstStyle>
           <a:p>
             <a:r>
-              <a:rPr lang="en-US" smtClean="0"/>
+              <a:rPr lang="en-US"/>
               <a:t>Click to edit Master title style</a:t>
             </a:r>
-            <a:endParaRPr lang="en-US"/>
           </a:p>
         </p:txBody>
       </p:sp>
@@ -1708,7 +1934,7 @@
           <a:p>
             <a:pPr lvl="0"/>
             <a:r>
-              <a:rPr lang="en-US" smtClean="0"/>
+              <a:rPr lang="en-US"/>
               <a:t>Click to edit Master text styles</a:t>
             </a:r>
           </a:p>
@@ -1731,7 +1957,7 @@
           <a:p>
             <a:fld id="{5BCAD085-E8A6-8845-BD4E-CB4CCA059FC4}" type="datetimeFigureOut">
               <a:rPr lang="en-US" smtClean="0"/>
-              <a:t>1/27/13</a:t>
+              <a:t>7/29/2026</a:t>
             </a:fld>
             <a:endParaRPr lang="en-US"/>
           </a:p>
@@ -1825,10 +2051,9 @@
           <a:lstStyle/>
           <a:p>
             <a:r>
-              <a:rPr lang="en-US" smtClean="0"/>
+              <a:rPr lang="en-US"/>
               <a:t>Click to edit Master title style</a:t>
             </a:r>
-            <a:endParaRPr lang="en-US"/>
           </a:p>
         </p:txBody>
       </p:sp>
@@ -1882,38 +2107,37 @@
           <a:p>
             <a:pPr lvl="0"/>
             <a:r>
-              <a:rPr lang="en-US" smtClean="0"/>
+              <a:rPr lang="en-US"/>
               <a:t>Click to edit Master text styles</a:t>
             </a:r>
           </a:p>
           <a:p>
             <a:pPr lvl="1"/>
             <a:r>
-              <a:rPr lang="en-US" smtClean="0"/>
+              <a:rPr lang="en-US"/>
               <a:t>Second level</a:t>
             </a:r>
           </a:p>
           <a:p>
             <a:pPr lvl="2"/>
             <a:r>
-              <a:rPr lang="en-US" smtClean="0"/>
+              <a:rPr lang="en-US"/>
               <a:t>Third level</a:t>
             </a:r>
           </a:p>
           <a:p>
             <a:pPr lvl="3"/>
             <a:r>
-              <a:rPr lang="en-US" smtClean="0"/>
+              <a:rPr lang="en-US"/>
               <a:t>Fourth level</a:t>
             </a:r>
           </a:p>
           <a:p>
             <a:pPr lvl="4"/>
             <a:r>
-              <a:rPr lang="en-US" smtClean="0"/>
+              <a:rPr lang="en-US"/>
               <a:t>Fifth level</a:t>
             </a:r>
-            <a:endParaRPr lang="en-US"/>
           </a:p>
         </p:txBody>
       </p:sp>
@@ -1967,38 +2191,37 @@
           <a:p>
             <a:pPr lvl="0"/>
             <a:r>
-              <a:rPr lang="en-US" smtClean="0"/>
+              <a:rPr lang="en-US"/>
               <a:t>Click to edit Master text styles</a:t>
             </a:r>
           </a:p>
           <a:p>
             <a:pPr lvl="1"/>
             <a:r>
-              <a:rPr lang="en-US" smtClean="0"/>
+              <a:rPr lang="en-US"/>
               <a:t>Second level</a:t>
             </a:r>
           </a:p>
           <a:p>
             <a:pPr lvl="2"/>
             <a:r>
-              <a:rPr lang="en-US" smtClean="0"/>
+              <a:rPr lang="en-US"/>
               <a:t>Third level</a:t>
             </a:r>
           </a:p>
           <a:p>
             <a:pPr lvl="3"/>
             <a:r>
-              <a:rPr lang="en-US" smtClean="0"/>
+              <a:rPr lang="en-US"/>
               <a:t>Fourth level</a:t>
             </a:r>
           </a:p>
           <a:p>
             <a:pPr lvl="4"/>
             <a:r>
-              <a:rPr lang="en-US" smtClean="0"/>
+              <a:rPr lang="en-US"/>
               <a:t>Fifth level</a:t>
             </a:r>
-            <a:endParaRPr lang="en-US"/>
           </a:p>
         </p:txBody>
       </p:sp>
@@ -2019,7 +2242,7 @@
           <a:p>
             <a:fld id="{5BCAD085-E8A6-8845-BD4E-CB4CCA059FC4}" type="datetimeFigureOut">
               <a:rPr lang="en-US" smtClean="0"/>
-              <a:t>1/27/13</a:t>
+              <a:t>7/29/2026</a:t>
             </a:fld>
             <a:endParaRPr lang="en-US"/>
           </a:p>
@@ -2117,10 +2340,9 @@
           </a:lstStyle>
           <a:p>
             <a:r>
-              <a:rPr lang="en-US" smtClean="0"/>
+              <a:rPr lang="en-US"/>
               <a:t>Click to edit Master title style</a:t>
             </a:r>
-            <a:endParaRPr lang="en-US"/>
           </a:p>
         </p:txBody>
       </p:sp>
@@ -2183,7 +2405,7 @@
           <a:p>
             <a:pPr lvl="0"/>
             <a:r>
-              <a:rPr lang="en-US" smtClean="0"/>
+              <a:rPr lang="en-US"/>
               <a:t>Click to edit Master text styles</a:t>
             </a:r>
           </a:p>
@@ -2239,38 +2461,37 @@
           <a:p>
             <a:pPr lvl="0"/>
             <a:r>
-              <a:rPr lang="en-US" smtClean="0"/>
+              <a:rPr lang="en-US"/>
               <a:t>Click to edit Master text styles</a:t>
             </a:r>
           </a:p>
           <a:p>
             <a:pPr lvl="1"/>
             <a:r>
-              <a:rPr lang="en-US" smtClean="0"/>
+              <a:rPr lang="en-US"/>
               <a:t>Second level</a:t>
             </a:r>
           </a:p>
           <a:p>
             <a:pPr lvl="2"/>
             <a:r>
-              <a:rPr lang="en-US" smtClean="0"/>
+              <a:rPr lang="en-US"/>
               <a:t>Third level</a:t>
             </a:r>
           </a:p>
           <a:p>
             <a:pPr lvl="3"/>
             <a:r>
-              <a:rPr lang="en-US" smtClean="0"/>
+              <a:rPr lang="en-US"/>
               <a:t>Fourth level</a:t>
             </a:r>
           </a:p>
           <a:p>
             <a:pPr lvl="4"/>
             <a:r>
-              <a:rPr lang="en-US" smtClean="0"/>
+              <a:rPr lang="en-US"/>
               <a:t>Fifth level</a:t>
             </a:r>
-            <a:endParaRPr lang="en-US"/>
           </a:p>
         </p:txBody>
       </p:sp>
@@ -2333,7 +2554,7 @@
           <a:p>
             <a:pPr lvl="0"/>
             <a:r>
-              <a:rPr lang="en-US" smtClean="0"/>
+              <a:rPr lang="en-US"/>
               <a:t>Click to edit Master text styles</a:t>
             </a:r>
           </a:p>
@@ -2389,38 +2610,37 @@
           <a:p>
             <a:pPr lvl="0"/>
             <a:r>
-              <a:rPr lang="en-US" smtClean="0"/>
+              <a:rPr lang="en-US"/>
               <a:t>Click to edit Master text styles</a:t>
             </a:r>
           </a:p>
           <a:p>
             <a:pPr lvl="1"/>
             <a:r>
-              <a:rPr lang="en-US" smtClean="0"/>
+              <a:rPr lang="en-US"/>
               <a:t>Second level</a:t>
             </a:r>
           </a:p>
           <a:p>
             <a:pPr lvl="2"/>
             <a:r>
-              <a:rPr lang="en-US" smtClean="0"/>
+              <a:rPr lang="en-US"/>
               <a:t>Third level</a:t>
             </a:r>
           </a:p>
           <a:p>
             <a:pPr lvl="3"/>
             <a:r>
-              <a:rPr lang="en-US" smtClean="0"/>
+              <a:rPr lang="en-US"/>
               <a:t>Fourth level</a:t>
             </a:r>
           </a:p>
           <a:p>
             <a:pPr lvl="4"/>
             <a:r>
-              <a:rPr lang="en-US" smtClean="0"/>
+              <a:rPr lang="en-US"/>
               <a:t>Fifth level</a:t>
             </a:r>
-            <a:endParaRPr lang="en-US"/>
           </a:p>
         </p:txBody>
       </p:sp>
@@ -2441,7 +2661,7 @@
           <a:p>
             <a:fld id="{5BCAD085-E8A6-8845-BD4E-CB4CCA059FC4}" type="datetimeFigureOut">
               <a:rPr lang="en-US" smtClean="0"/>
-              <a:t>1/27/13</a:t>
+              <a:t>7/29/2026</a:t>
             </a:fld>
             <a:endParaRPr lang="en-US"/>
           </a:p>
@@ -2535,10 +2755,9 @@
           <a:lstStyle/>
           <a:p>
             <a:r>
-              <a:rPr lang="en-US" smtClean="0"/>
+              <a:rPr lang="en-US"/>
               <a:t>Click to edit Master title style</a:t>
             </a:r>
-            <a:endParaRPr lang="en-US"/>
           </a:p>
         </p:txBody>
       </p:sp>
@@ -2559,7 +2778,7 @@
           <a:p>
             <a:fld id="{5BCAD085-E8A6-8845-BD4E-CB4CCA059FC4}" type="datetimeFigureOut">
               <a:rPr lang="en-US" smtClean="0"/>
-              <a:t>1/27/13</a:t>
+              <a:t>7/29/2026</a:t>
             </a:fld>
             <a:endParaRPr lang="en-US"/>
           </a:p>
@@ -2654,7 +2873,7 @@
           <a:p>
             <a:fld id="{5BCAD085-E8A6-8845-BD4E-CB4CCA059FC4}" type="datetimeFigureOut">
               <a:rPr lang="en-US" smtClean="0"/>
-              <a:t>1/27/13</a:t>
+              <a:t>7/29/2026</a:t>
             </a:fld>
             <a:endParaRPr lang="en-US"/>
           </a:p>
@@ -2757,10 +2976,9 @@
           </a:lstStyle>
           <a:p>
             <a:r>
-              <a:rPr lang="en-US" smtClean="0"/>
+              <a:rPr lang="en-US"/>
               <a:t>Click to edit Master title style</a:t>
             </a:r>
-            <a:endParaRPr lang="en-US"/>
           </a:p>
         </p:txBody>
       </p:sp>
@@ -2814,38 +3032,37 @@
           <a:p>
             <a:pPr lvl="0"/>
             <a:r>
-              <a:rPr lang="en-US" smtClean="0"/>
+              <a:rPr lang="en-US"/>
               <a:t>Click to edit Master text styles</a:t>
             </a:r>
           </a:p>
           <a:p>
             <a:pPr lvl="1"/>
             <a:r>
-              <a:rPr lang="en-US" smtClean="0"/>
+              <a:rPr lang="en-US"/>
               <a:t>Second level</a:t>
             </a:r>
           </a:p>
           <a:p>
             <a:pPr lvl="2"/>
             <a:r>
-              <a:rPr lang="en-US" smtClean="0"/>
+              <a:rPr lang="en-US"/>
               <a:t>Third level</a:t>
             </a:r>
           </a:p>
           <a:p>
             <a:pPr lvl="3"/>
             <a:r>
-              <a:rPr lang="en-US" smtClean="0"/>
+              <a:rPr lang="en-US"/>
               <a:t>Fourth level</a:t>
             </a:r>
           </a:p>
           <a:p>
             <a:pPr lvl="4"/>
             <a:r>
-              <a:rPr lang="en-US" smtClean="0"/>
+              <a:rPr lang="en-US"/>
               <a:t>Fifth level</a:t>
             </a:r>
-            <a:endParaRPr lang="en-US"/>
           </a:p>
         </p:txBody>
       </p:sp>
@@ -2908,7 +3125,7 @@
           <a:p>
             <a:pPr lvl="0"/>
             <a:r>
-              <a:rPr lang="en-US" smtClean="0"/>
+              <a:rPr lang="en-US"/>
               <a:t>Click to edit Master text styles</a:t>
             </a:r>
           </a:p>
@@ -2931,7 +3148,7 @@
           <a:p>
             <a:fld id="{5BCAD085-E8A6-8845-BD4E-CB4CCA059FC4}" type="datetimeFigureOut">
               <a:rPr lang="en-US" smtClean="0"/>
-              <a:t>1/27/13</a:t>
+              <a:t>7/29/2026</a:t>
             </a:fld>
             <a:endParaRPr lang="en-US"/>
           </a:p>
@@ -3034,10 +3251,9 @@
           </a:lstStyle>
           <a:p>
             <a:r>
-              <a:rPr lang="en-US" smtClean="0"/>
+              <a:rPr lang="en-US"/>
               <a:t>Click to edit Master title style</a:t>
             </a:r>
-            <a:endParaRPr lang="en-US"/>
           </a:p>
         </p:txBody>
       </p:sp>
@@ -3161,7 +3377,7 @@
           <a:p>
             <a:pPr lvl="0"/>
             <a:r>
-              <a:rPr lang="en-US" smtClean="0"/>
+              <a:rPr lang="en-US"/>
               <a:t>Click to edit Master text styles</a:t>
             </a:r>
           </a:p>
@@ -3184,7 +3400,7 @@
           <a:p>
             <a:fld id="{5BCAD085-E8A6-8845-BD4E-CB4CCA059FC4}" type="datetimeFigureOut">
               <a:rPr lang="en-US" smtClean="0"/>
-              <a:t>1/27/13</a:t>
+              <a:t>7/29/2026</a:t>
             </a:fld>
             <a:endParaRPr lang="en-US"/>
           </a:p>
@@ -3293,10 +3509,9 @@
           <a:lstStyle/>
           <a:p>
             <a:r>
-              <a:rPr lang="en-US" smtClean="0"/>
+              <a:rPr lang="en-US"/>
               <a:t>Click to edit Master title style</a:t>
             </a:r>
-            <a:endParaRPr lang="en-US"/>
           </a:p>
         </p:txBody>
       </p:sp>
@@ -3327,38 +3542,37 @@
           <a:p>
             <a:pPr lvl="0"/>
             <a:r>
-              <a:rPr lang="en-US" smtClean="0"/>
+              <a:rPr lang="en-US"/>
               <a:t>Click to edit Master text styles</a:t>
             </a:r>
           </a:p>
           <a:p>
             <a:pPr lvl="1"/>
             <a:r>
-              <a:rPr lang="en-US" smtClean="0"/>
+              <a:rPr lang="en-US"/>
               <a:t>Second level</a:t>
             </a:r>
           </a:p>
           <a:p>
             <a:pPr lvl="2"/>
             <a:r>
-              <a:rPr lang="en-US" smtClean="0"/>
+              <a:rPr lang="en-US"/>
               <a:t>Third level</a:t>
             </a:r>
           </a:p>
           <a:p>
             <a:pPr lvl="3"/>
             <a:r>
-              <a:rPr lang="en-US" smtClean="0"/>
+              <a:rPr lang="en-US"/>
               <a:t>Fourth level</a:t>
             </a:r>
           </a:p>
           <a:p>
             <a:pPr lvl="4"/>
             <a:r>
-              <a:rPr lang="en-US" smtClean="0"/>
+              <a:rPr lang="en-US"/>
               <a:t>Fifth level</a:t>
             </a:r>
-            <a:endParaRPr lang="en-US"/>
           </a:p>
         </p:txBody>
       </p:sp>
@@ -3397,7 +3611,7 @@
           <a:p>
             <a:fld id="{5BCAD085-E8A6-8845-BD4E-CB4CCA059FC4}" type="datetimeFigureOut">
               <a:rPr lang="en-US" smtClean="0"/>
-              <a:t>1/27/13</a:t>
+              <a:t>7/29/2026</a:t>
             </a:fld>
             <a:endParaRPr lang="en-US"/>
           </a:p>
@@ -3756,7 +3970,7 @@
 </file>
 
 <file path=ppt/slides/slide1.xml><?xml version="1.0" encoding="utf-8"?>
-<p:sld xmlns:a="http://schemas.openxmlformats.org/drawingml/2006/main" xmlns:p="http://schemas.openxmlformats.org/presentationml/2006/main" xmlns:r="http://schemas.openxmlformats.org/officeDocument/2006/relationships">
+<p:sld xmlns:a="http://schemas.openxmlformats.org/drawingml/2006/main" xmlns:r="http://schemas.openxmlformats.org/officeDocument/2006/relationships" xmlns:p="http://schemas.openxmlformats.org/presentationml/2006/main">
   <p:cSld>
     <p:bg>
       <p:bgPr>
@@ -3772,7 +3986,14 @@
         <p:cNvGrpSpPr/>
         <p:nvPr/>
       </p:nvGrpSpPr>
-      <p:grpSpPr/>
+      <p:grpSpPr>
+        <a:xfrm>
+          <a:off x="0" y="0"/>
+          <a:ext cx="0" cy="0"/>
+          <a:chOff x="0" y="0"/>
+          <a:chExt cx="0" cy="0"/>
+        </a:xfrm>
+      </p:grpSpPr>
       <p:sp>
         <p:nvSpPr>
           <p:cNvPr id="2" name="Oval 1"/>
@@ -3814,6 +4035,7 @@
           <a:lstStyle/>
           <a:p>
             <a:pPr algn="ctr"/>
+            <a:endParaRPr/>
           </a:p>
         </p:txBody>
       </p:sp>
@@ -3858,6 +4080,7 @@
           <a:lstStyle/>
           <a:p>
             <a:pPr algn="ctr"/>
+            <a:endParaRPr/>
           </a:p>
         </p:txBody>
       </p:sp>
@@ -3878,7 +4101,7 @@
           <a:noFill/>
         </p:spPr>
         <p:txBody>
-          <a:bodyPr wrap="square" anchor="t" lIns="0" rIns="0" tIns="0" bIns="0">
+          <a:bodyPr wrap="square" lIns="0" tIns="0" rIns="0" bIns="0" anchor="t">
             <a:spAutoFit/>
           </a:bodyPr>
           <a:lstStyle/>
@@ -3917,7 +4140,7 @@
           <a:noFill/>
         </p:spPr>
         <p:txBody>
-          <a:bodyPr wrap="square" anchor="t" lIns="0" rIns="0" tIns="0" bIns="0">
+          <a:bodyPr wrap="square" lIns="0" tIns="0" rIns="0" bIns="0" anchor="t">
             <a:spAutoFit/>
           </a:bodyPr>
           <a:lstStyle/>
@@ -3972,7 +4195,7 @@
           <a:noFill/>
         </p:spPr>
         <p:txBody>
-          <a:bodyPr wrap="square" anchor="t" lIns="0" rIns="0" tIns="0" bIns="0">
+          <a:bodyPr wrap="square" lIns="0" tIns="0" rIns="0" bIns="0" anchor="t">
             <a:spAutoFit/>
           </a:bodyPr>
           <a:lstStyle/>
@@ -4031,7 +4254,7 @@
           </a:fontRef>
         </p:style>
         <p:txBody>
-          <a:bodyPr rtlCol="0" anchor="ctr" wrap="none" lIns="0" rIns="0" tIns="0" bIns="0"/>
+          <a:bodyPr wrap="none" lIns="0" tIns="0" rIns="0" bIns="0" rtlCol="0" anchor="ctr"/>
           <a:lstStyle/>
           <a:p>
             <a:pPr algn="ctr"/>
@@ -4064,7 +4287,7 @@
           <a:noFill/>
         </p:spPr>
         <p:txBody>
-          <a:bodyPr wrap="square" anchor="ctr" lIns="0" rIns="0" tIns="0" bIns="0">
+          <a:bodyPr wrap="square" lIns="0" tIns="0" rIns="0" bIns="0" anchor="ctr">
             <a:spAutoFit/>
           </a:bodyPr>
           <a:lstStyle/>
@@ -4129,6 +4352,7 @@
           <a:lstStyle/>
           <a:p>
             <a:pPr algn="ctr"/>
+            <a:endParaRPr/>
           </a:p>
         </p:txBody>
       </p:sp>
@@ -4140,7 +4364,7 @@
         </p:nvSpPr>
         <p:spPr>
           <a:xfrm>
-            <a:off x="1051560" y="5230368"/>
+            <a:off x="1051560" y="5115630"/>
             <a:ext cx="5212080" cy="274320"/>
           </a:xfrm>
           <a:prstGeom prst="rect">
@@ -4149,7 +4373,7 @@
           <a:noFill/>
         </p:spPr>
         <p:txBody>
-          <a:bodyPr wrap="square" anchor="t" lIns="0" rIns="0" tIns="0" bIns="0">
+          <a:bodyPr wrap="square" lIns="0" tIns="0" rIns="0" bIns="0" anchor="t">
             <a:spAutoFit/>
           </a:bodyPr>
           <a:lstStyle/>
@@ -4160,7 +4384,7 @@
               </a:lnSpc>
             </a:pPr>
             <a:r>
-              <a:rPr sz="1100" b="1" i="0">
+              <a:rPr sz="1100" b="1" i="0" dirty="0">
                 <a:solidFill>
                   <a:srgbClr val="2FBF9F"/>
                 </a:solidFill>
@@ -4179,8 +4403,8 @@
         </p:nvSpPr>
         <p:spPr>
           <a:xfrm>
-            <a:off x="1051560" y="5504688"/>
-            <a:ext cx="5212080" cy="320040"/>
+            <a:off x="1051560" y="5326380"/>
+            <a:ext cx="5212080" cy="461665"/>
           </a:xfrm>
           <a:prstGeom prst="rect">
             <a:avLst/>
@@ -4188,7 +4412,7 @@
           <a:noFill/>
         </p:spPr>
         <p:txBody>
-          <a:bodyPr wrap="square" anchor="t" lIns="0" rIns="0" tIns="0" bIns="0">
+          <a:bodyPr wrap="square" lIns="0" tIns="0" rIns="0" bIns="0" anchor="t">
             <a:spAutoFit/>
           </a:bodyPr>
           <a:lstStyle/>
@@ -4199,14 +4423,84 @@
               </a:lnSpc>
             </a:pPr>
             <a:r>
-              <a:rPr sz="1500" b="0" i="0">
+              <a:rPr sz="1500" b="0" i="0" dirty="0">
                 <a:solidFill>
                   <a:srgbClr val="FFFFFF"/>
                 </a:solidFill>
                 <a:latin typeface="Calibri"/>
               </a:rPr>
-              <a:t>Uriel Atzmon  ·  Victoria Chuykina</a:t>
-            </a:r>
+              <a:t>Uriel Atzmon</a:t>
+            </a:r>
+            <a:r>
+              <a:rPr lang="en-US" sz="1500" b="0" i="0" dirty="0">
+                <a:solidFill>
+                  <a:srgbClr val="FFFFFF"/>
+                </a:solidFill>
+                <a:latin typeface="Calibri"/>
+              </a:rPr>
+              <a:t>, ID – 209307172</a:t>
+            </a:r>
+          </a:p>
+          <a:p>
+            <a:r>
+              <a:rPr sz="1500" b="0" i="0" dirty="0">
+                <a:solidFill>
+                  <a:srgbClr val="FFFFFF"/>
+                </a:solidFill>
+                <a:latin typeface="Calibri"/>
+              </a:rPr>
+              <a:t>Victoria </a:t>
+            </a:r>
+            <a:r>
+              <a:rPr sz="1500" b="0" i="0" dirty="0" err="1">
+                <a:solidFill>
+                  <a:srgbClr val="FFFFFF"/>
+                </a:solidFill>
+                <a:latin typeface="Calibri"/>
+              </a:rPr>
+              <a:t>Chuy</a:t>
+            </a:r>
+            <a:r>
+              <a:rPr lang="en-US" sz="1500" b="0" i="0" dirty="0" err="1">
+                <a:solidFill>
+                  <a:srgbClr val="FFFFFF"/>
+                </a:solidFill>
+                <a:latin typeface="Calibri"/>
+              </a:rPr>
+              <a:t>k</a:t>
+            </a:r>
+            <a:r>
+              <a:rPr sz="1500" b="0" i="0" dirty="0" err="1">
+                <a:solidFill>
+                  <a:srgbClr val="FFFFFF"/>
+                </a:solidFill>
+                <a:latin typeface="Calibri"/>
+              </a:rPr>
+              <a:t>ina</a:t>
+            </a:r>
+            <a:r>
+              <a:rPr lang="en-US" sz="1500" dirty="0">
+                <a:solidFill>
+                  <a:srgbClr val="FFFFFF"/>
+                </a:solidFill>
+                <a:latin typeface="Calibri"/>
+              </a:rPr>
+              <a:t>, ID - </a:t>
+            </a:r>
+            <a:r>
+              <a:rPr lang="en-US" sz="1500" dirty="0">
+                <a:solidFill>
+                  <a:srgbClr val="FFFFFF"/>
+                </a:solidFill>
+              </a:rPr>
+              <a:t>321544512</a:t>
+            </a:r>
+            <a:endParaRPr sz="1500" b="0" i="0" dirty="0">
+              <a:solidFill>
+                <a:srgbClr val="FFFFFF"/>
+              </a:solidFill>
+              <a:latin typeface="Calibri"/>
+            </a:endParaRPr>
           </a:p>
         </p:txBody>
       </p:sp>
@@ -4227,7 +4521,7 @@
           <a:noFill/>
         </p:spPr>
         <p:txBody>
-          <a:bodyPr wrap="square" anchor="t" lIns="0" rIns="0" tIns="0" bIns="0">
+          <a:bodyPr wrap="square" lIns="0" tIns="0" rIns="0" bIns="0" anchor="t">
             <a:spAutoFit/>
           </a:bodyPr>
           <a:lstStyle/>
@@ -4258,7 +4552,7 @@
 </file>
 
 <file path=ppt/slides/slide2.xml><?xml version="1.0" encoding="utf-8"?>
-<p:sld xmlns:a="http://schemas.openxmlformats.org/drawingml/2006/main" xmlns:p="http://schemas.openxmlformats.org/presentationml/2006/main" xmlns:r="http://schemas.openxmlformats.org/officeDocument/2006/relationships">
+<p:sld xmlns:a="http://schemas.openxmlformats.org/drawingml/2006/main" xmlns:r="http://schemas.openxmlformats.org/officeDocument/2006/relationships" xmlns:p="http://schemas.openxmlformats.org/presentationml/2006/main">
   <p:cSld>
     <p:bg>
       <p:bgPr>
@@ -4274,7 +4568,14 @@
         <p:cNvGrpSpPr/>
         <p:nvPr/>
       </p:nvGrpSpPr>
-      <p:grpSpPr/>
+      <p:grpSpPr>
+        <a:xfrm>
+          <a:off x="0" y="0"/>
+          <a:ext cx="0" cy="0"/>
+          <a:chOff x="0" y="0"/>
+          <a:chExt cx="0" cy="0"/>
+        </a:xfrm>
+      </p:grpSpPr>
       <p:sp>
         <p:nvSpPr>
           <p:cNvPr id="2" name="TextBox 1"/>
@@ -4292,7 +4593,7 @@
           <a:noFill/>
         </p:spPr>
         <p:txBody>
-          <a:bodyPr wrap="square" anchor="t" lIns="0" rIns="0" tIns="0" bIns="0">
+          <a:bodyPr wrap="square" lIns="0" tIns="0" rIns="0" bIns="0" anchor="t">
             <a:spAutoFit/>
           </a:bodyPr>
           <a:lstStyle/>
@@ -4331,7 +4632,7 @@
           <a:noFill/>
         </p:spPr>
         <p:txBody>
-          <a:bodyPr wrap="square" anchor="t" lIns="0" rIns="0" tIns="0" bIns="0">
+          <a:bodyPr wrap="square" lIns="0" tIns="0" rIns="0" bIns="0" anchor="t">
             <a:spAutoFit/>
           </a:bodyPr>
           <a:lstStyle/>
@@ -4390,7 +4691,7 @@
           </a:fontRef>
         </p:style>
         <p:txBody>
-          <a:bodyPr rtlCol="0" anchor="ctr" wrap="none" lIns="0" rIns="0" tIns="0" bIns="0"/>
+          <a:bodyPr wrap="none" lIns="0" tIns="0" rIns="0" bIns="0" rtlCol="0" anchor="ctr"/>
           <a:lstStyle/>
           <a:p>
             <a:pPr algn="ctr"/>
@@ -4423,7 +4724,7 @@
           <a:noFill/>
         </p:spPr>
         <p:txBody>
-          <a:bodyPr wrap="square" anchor="ctr" lIns="0" rIns="0" tIns="0" bIns="0">
+          <a:bodyPr wrap="square" lIns="0" tIns="0" rIns="0" bIns="0" anchor="ctr">
             <a:spAutoFit/>
           </a:bodyPr>
           <a:lstStyle/>
@@ -4488,6 +4789,7 @@
           <a:lstStyle/>
           <a:p>
             <a:pPr algn="ctr"/>
+            <a:endParaRPr/>
           </a:p>
         </p:txBody>
       </p:sp>
@@ -4508,7 +4810,7 @@
           <a:noFill/>
         </p:spPr>
         <p:txBody>
-          <a:bodyPr wrap="square" anchor="ctr" lIns="0" rIns="0" tIns="0" bIns="0">
+          <a:bodyPr wrap="square" lIns="0" tIns="0" rIns="0" bIns="0" anchor="ctr">
             <a:spAutoFit/>
           </a:bodyPr>
           <a:lstStyle/>
@@ -4563,7 +4865,7 @@
           <a:noFill/>
         </p:spPr>
         <p:txBody>
-          <a:bodyPr wrap="square" anchor="ctr" lIns="0" rIns="0" tIns="0" bIns="0">
+          <a:bodyPr wrap="square" lIns="0" tIns="0" rIns="0" bIns="0" anchor="ctr">
             <a:spAutoFit/>
           </a:bodyPr>
           <a:lstStyle/>
@@ -4657,7 +4959,7 @@
           </a:fontRef>
         </p:style>
         <p:txBody>
-          <a:bodyPr rtlCol="0" anchor="ctr" wrap="none" lIns="0" rIns="0" tIns="0" bIns="0"/>
+          <a:bodyPr wrap="none" lIns="0" tIns="0" rIns="0" bIns="0" rtlCol="0" anchor="ctr"/>
           <a:lstStyle/>
           <a:p>
             <a:pPr algn="ctr"/>
@@ -4690,7 +4992,7 @@
           <a:noFill/>
         </p:spPr>
         <p:txBody>
-          <a:bodyPr wrap="square" anchor="ctr" lIns="0" rIns="0" tIns="0" bIns="0">
+          <a:bodyPr wrap="square" lIns="0" tIns="0" rIns="0" bIns="0" anchor="ctr">
             <a:spAutoFit/>
           </a:bodyPr>
           <a:lstStyle/>
@@ -4755,6 +5057,7 @@
           <a:lstStyle/>
           <a:p>
             <a:pPr algn="ctr"/>
+            <a:endParaRPr/>
           </a:p>
         </p:txBody>
       </p:sp>
@@ -4775,7 +5078,7 @@
           <a:noFill/>
         </p:spPr>
         <p:txBody>
-          <a:bodyPr wrap="square" anchor="ctr" lIns="0" rIns="0" tIns="0" bIns="0">
+          <a:bodyPr wrap="square" lIns="0" tIns="0" rIns="0" bIns="0" anchor="ctr">
             <a:spAutoFit/>
           </a:bodyPr>
           <a:lstStyle/>
@@ -4814,7 +5117,7 @@
           <a:noFill/>
         </p:spPr>
         <p:txBody>
-          <a:bodyPr wrap="square" anchor="ctr" lIns="0" rIns="0" tIns="0" bIns="0">
+          <a:bodyPr wrap="square" lIns="0" tIns="0" rIns="0" bIns="0" anchor="ctr">
             <a:spAutoFit/>
           </a:bodyPr>
           <a:lstStyle/>
@@ -4825,7 +5128,7 @@
               </a:lnSpc>
             </a:pPr>
             <a:r>
-              <a:rPr sz="950" b="0" i="1">
+              <a:rPr sz="950" b="0" i="1" dirty="0">
                 <a:solidFill>
                   <a:srgbClr val="5A6678"/>
                 </a:solidFill>
@@ -4908,7 +5211,7 @@
           </a:fontRef>
         </p:style>
         <p:txBody>
-          <a:bodyPr rtlCol="0" anchor="ctr" wrap="none" lIns="0" rIns="0" tIns="0" bIns="0"/>
+          <a:bodyPr wrap="none" lIns="0" tIns="0" rIns="0" bIns="0" rtlCol="0" anchor="ctr"/>
           <a:lstStyle/>
           <a:p>
             <a:pPr algn="ctr"/>
@@ -4941,7 +5244,7 @@
           <a:noFill/>
         </p:spPr>
         <p:txBody>
-          <a:bodyPr wrap="square" anchor="ctr" lIns="0" rIns="0" tIns="0" bIns="0">
+          <a:bodyPr wrap="square" lIns="0" tIns="0" rIns="0" bIns="0" anchor="ctr">
             <a:spAutoFit/>
           </a:bodyPr>
           <a:lstStyle/>
@@ -5006,6 +5309,7 @@
           <a:lstStyle/>
           <a:p>
             <a:pPr algn="ctr"/>
+            <a:endParaRPr/>
           </a:p>
         </p:txBody>
       </p:sp>
@@ -5026,7 +5330,7 @@
           <a:noFill/>
         </p:spPr>
         <p:txBody>
-          <a:bodyPr wrap="square" anchor="ctr" lIns="0" rIns="0" tIns="0" bIns="0">
+          <a:bodyPr wrap="square" lIns="0" tIns="0" rIns="0" bIns="0" anchor="ctr">
             <a:spAutoFit/>
           </a:bodyPr>
           <a:lstStyle/>
@@ -5081,7 +5385,7 @@
           <a:noFill/>
         </p:spPr>
         <p:txBody>
-          <a:bodyPr wrap="square" anchor="ctr" lIns="0" rIns="0" tIns="0" bIns="0">
+          <a:bodyPr wrap="square" lIns="0" tIns="0" rIns="0" bIns="0" anchor="ctr">
             <a:spAutoFit/>
           </a:bodyPr>
           <a:lstStyle/>
@@ -5175,7 +5479,7 @@
           </a:fontRef>
         </p:style>
         <p:txBody>
-          <a:bodyPr rtlCol="0" anchor="ctr" wrap="none" lIns="0" rIns="0" tIns="0" bIns="0"/>
+          <a:bodyPr wrap="none" lIns="0" tIns="0" rIns="0" bIns="0" rtlCol="0" anchor="ctr"/>
           <a:lstStyle/>
           <a:p>
             <a:pPr algn="ctr"/>
@@ -5208,7 +5512,7 @@
           <a:noFill/>
         </p:spPr>
         <p:txBody>
-          <a:bodyPr wrap="square" anchor="ctr" lIns="0" rIns="0" tIns="0" bIns="0">
+          <a:bodyPr wrap="square" lIns="0" tIns="0" rIns="0" bIns="0" anchor="ctr">
             <a:spAutoFit/>
           </a:bodyPr>
           <a:lstStyle/>
@@ -5273,6 +5577,7 @@
           <a:lstStyle/>
           <a:p>
             <a:pPr algn="ctr"/>
+            <a:endParaRPr/>
           </a:p>
         </p:txBody>
       </p:sp>
@@ -5293,7 +5598,7 @@
           <a:noFill/>
         </p:spPr>
         <p:txBody>
-          <a:bodyPr wrap="square" anchor="ctr" lIns="0" rIns="0" tIns="0" bIns="0">
+          <a:bodyPr wrap="square" lIns="0" tIns="0" rIns="0" bIns="0" anchor="ctr">
             <a:spAutoFit/>
           </a:bodyPr>
           <a:lstStyle/>
@@ -5348,7 +5653,7 @@
           <a:noFill/>
         </p:spPr>
         <p:txBody>
-          <a:bodyPr wrap="square" anchor="ctr" lIns="0" rIns="0" tIns="0" bIns="0">
+          <a:bodyPr wrap="square" lIns="0" tIns="0" rIns="0" bIns="0" anchor="ctr">
             <a:spAutoFit/>
           </a:bodyPr>
           <a:lstStyle/>
@@ -5442,7 +5747,7 @@
           </a:fontRef>
         </p:style>
         <p:txBody>
-          <a:bodyPr rtlCol="0" anchor="ctr" wrap="none" lIns="0" rIns="0" tIns="0" bIns="0"/>
+          <a:bodyPr wrap="none" lIns="0" tIns="0" rIns="0" bIns="0" rtlCol="0" anchor="ctr"/>
           <a:lstStyle/>
           <a:p>
             <a:pPr algn="ctr"/>
@@ -5475,7 +5780,7 @@
           <a:noFill/>
         </p:spPr>
         <p:txBody>
-          <a:bodyPr wrap="square" anchor="ctr" lIns="0" rIns="0" tIns="0" bIns="0">
+          <a:bodyPr wrap="square" lIns="0" tIns="0" rIns="0" bIns="0" anchor="ctr">
             <a:spAutoFit/>
           </a:bodyPr>
           <a:lstStyle/>
@@ -5540,6 +5845,7 @@
           <a:lstStyle/>
           <a:p>
             <a:pPr algn="ctr"/>
+            <a:endParaRPr/>
           </a:p>
         </p:txBody>
       </p:sp>
@@ -5560,7 +5866,7 @@
           <a:noFill/>
         </p:spPr>
         <p:txBody>
-          <a:bodyPr wrap="square" anchor="ctr" lIns="0" rIns="0" tIns="0" bIns="0">
+          <a:bodyPr wrap="square" lIns="0" tIns="0" rIns="0" bIns="0" anchor="ctr">
             <a:spAutoFit/>
           </a:bodyPr>
           <a:lstStyle/>
@@ -5599,7 +5905,7 @@
           <a:noFill/>
         </p:spPr>
         <p:txBody>
-          <a:bodyPr wrap="square" anchor="ctr" lIns="0" rIns="0" tIns="0" bIns="0">
+          <a:bodyPr wrap="square" lIns="0" tIns="0" rIns="0" bIns="0" anchor="ctr">
             <a:spAutoFit/>
           </a:bodyPr>
           <a:lstStyle/>
@@ -5638,7 +5944,7 @@
           <a:noFill/>
         </p:spPr>
         <p:txBody>
-          <a:bodyPr wrap="square" anchor="t" lIns="0" rIns="0" tIns="0" bIns="0">
+          <a:bodyPr wrap="square" lIns="0" tIns="0" rIns="0" bIns="0" anchor="t">
             <a:spAutoFit/>
           </a:bodyPr>
           <a:lstStyle/>
@@ -5669,7 +5975,7 @@
 </file>
 
 <file path=ppt/slides/slide3.xml><?xml version="1.0" encoding="utf-8"?>
-<p:sld xmlns:a="http://schemas.openxmlformats.org/drawingml/2006/main" xmlns:p="http://schemas.openxmlformats.org/presentationml/2006/main" xmlns:r="http://schemas.openxmlformats.org/officeDocument/2006/relationships">
+<p:sld xmlns:a="http://schemas.openxmlformats.org/drawingml/2006/main" xmlns:r="http://schemas.openxmlformats.org/officeDocument/2006/relationships" xmlns:p="http://schemas.openxmlformats.org/presentationml/2006/main">
   <p:cSld>
     <p:bg>
       <p:bgPr>
@@ -5685,7 +5991,14 @@
         <p:cNvGrpSpPr/>
         <p:nvPr/>
       </p:nvGrpSpPr>
-      <p:grpSpPr/>
+      <p:grpSpPr>
+        <a:xfrm>
+          <a:off x="0" y="0"/>
+          <a:ext cx="0" cy="0"/>
+          <a:chOff x="0" y="0"/>
+          <a:chExt cx="0" cy="0"/>
+        </a:xfrm>
+      </p:grpSpPr>
       <p:sp>
         <p:nvSpPr>
           <p:cNvPr id="2" name="TextBox 1"/>
@@ -5703,7 +6016,7 @@
           <a:noFill/>
         </p:spPr>
         <p:txBody>
-          <a:bodyPr wrap="square" anchor="t" lIns="0" rIns="0" tIns="0" bIns="0">
+          <a:bodyPr wrap="square" lIns="0" tIns="0" rIns="0" bIns="0" anchor="t">
             <a:spAutoFit/>
           </a:bodyPr>
           <a:lstStyle/>
@@ -5742,7 +6055,7 @@
           <a:noFill/>
         </p:spPr>
         <p:txBody>
-          <a:bodyPr wrap="square" anchor="t" lIns="0" rIns="0" tIns="0" bIns="0">
+          <a:bodyPr wrap="square" lIns="0" tIns="0" rIns="0" bIns="0" anchor="t">
             <a:spAutoFit/>
           </a:bodyPr>
           <a:lstStyle/>
@@ -5781,7 +6094,7 @@
           <a:noFill/>
         </p:spPr>
         <p:txBody>
-          <a:bodyPr wrap="square" anchor="t" lIns="0" rIns="0" tIns="0" bIns="0">
+          <a:bodyPr wrap="square" lIns="0" tIns="0" rIns="0" bIns="0" anchor="t">
             <a:spAutoFit/>
           </a:bodyPr>
           <a:lstStyle/>
@@ -5820,7 +6133,7 @@
           <a:noFill/>
         </p:spPr>
         <p:txBody>
-          <a:bodyPr wrap="square" lIns="0" rIns="0" tIns="0" bIns="0">
+          <a:bodyPr wrap="square" lIns="0" tIns="0" rIns="0" bIns="0">
             <a:spAutoFit/>
           </a:bodyPr>
           <a:lstStyle/>
@@ -5989,6 +6302,7 @@
           <a:lstStyle/>
           <a:p>
             <a:pPr algn="ctr"/>
+            <a:endParaRPr/>
           </a:p>
         </p:txBody>
       </p:sp>
@@ -6009,7 +6323,7 @@
           <a:noFill/>
         </p:spPr>
         <p:txBody>
-          <a:bodyPr wrap="square" anchor="t" lIns="0" rIns="0" tIns="0" bIns="0">
+          <a:bodyPr wrap="square" lIns="0" tIns="0" rIns="0" bIns="0" anchor="t">
             <a:spAutoFit/>
           </a:bodyPr>
           <a:lstStyle/>
@@ -6048,7 +6362,7 @@
           <a:noFill/>
         </p:spPr>
         <p:txBody>
-          <a:bodyPr wrap="square" anchor="t" lIns="0" rIns="0" tIns="0" bIns="0">
+          <a:bodyPr wrap="square" lIns="0" tIns="0" rIns="0" bIns="0" anchor="t">
             <a:spAutoFit/>
           </a:bodyPr>
           <a:lstStyle/>
@@ -6087,7 +6401,7 @@
           <a:noFill/>
         </p:spPr>
         <p:txBody>
-          <a:bodyPr wrap="square" anchor="t" lIns="0" rIns="0" tIns="0" bIns="0">
+          <a:bodyPr wrap="square" lIns="0" tIns="0" rIns="0" bIns="0" anchor="t">
             <a:spAutoFit/>
           </a:bodyPr>
           <a:lstStyle/>
@@ -6146,7 +6460,7 @@
           </a:fontRef>
         </p:style>
         <p:txBody>
-          <a:bodyPr rtlCol="0" anchor="ctr" wrap="none" lIns="0" rIns="0" tIns="0" bIns="0"/>
+          <a:bodyPr wrap="none" lIns="0" tIns="0" rIns="0" bIns="0" rtlCol="0" anchor="ctr"/>
           <a:lstStyle/>
           <a:p>
             <a:pPr algn="ctr"/>
@@ -6179,7 +6493,7 @@
           <a:noFill/>
         </p:spPr>
         <p:txBody>
-          <a:bodyPr wrap="square" anchor="t" lIns="0" rIns="0" tIns="0" bIns="0">
+          <a:bodyPr wrap="square" lIns="0" tIns="0" rIns="0" bIns="0" anchor="t">
             <a:spAutoFit/>
           </a:bodyPr>
           <a:lstStyle/>
@@ -6218,7 +6532,7 @@
           <a:noFill/>
         </p:spPr>
         <p:txBody>
-          <a:bodyPr wrap="square" anchor="t" lIns="0" rIns="0" tIns="0" bIns="0">
+          <a:bodyPr wrap="square" lIns="0" tIns="0" rIns="0" bIns="0" anchor="t">
             <a:spAutoFit/>
           </a:bodyPr>
           <a:lstStyle/>
@@ -6277,7 +6591,7 @@
           </a:fontRef>
         </p:style>
         <p:txBody>
-          <a:bodyPr rtlCol="0" anchor="ctr" wrap="none" lIns="0" rIns="0" tIns="0" bIns="0"/>
+          <a:bodyPr wrap="none" lIns="0" tIns="0" rIns="0" bIns="0" rtlCol="0" anchor="ctr"/>
           <a:lstStyle/>
           <a:p>
             <a:pPr algn="ctr"/>
@@ -6310,7 +6624,7 @@
           <a:noFill/>
         </p:spPr>
         <p:txBody>
-          <a:bodyPr wrap="square" anchor="t" lIns="0" rIns="0" tIns="0" bIns="0">
+          <a:bodyPr wrap="square" lIns="0" tIns="0" rIns="0" bIns="0" anchor="t">
             <a:spAutoFit/>
           </a:bodyPr>
           <a:lstStyle/>
@@ -6349,7 +6663,7 @@
           <a:noFill/>
         </p:spPr>
         <p:txBody>
-          <a:bodyPr wrap="square" anchor="t" lIns="0" rIns="0" tIns="0" bIns="0">
+          <a:bodyPr wrap="square" lIns="0" tIns="0" rIns="0" bIns="0" anchor="t">
             <a:spAutoFit/>
           </a:bodyPr>
           <a:lstStyle/>
@@ -6408,7 +6722,7 @@
           </a:fontRef>
         </p:style>
         <p:txBody>
-          <a:bodyPr rtlCol="0" anchor="ctr" wrap="none" lIns="0" rIns="0" tIns="0" bIns="0"/>
+          <a:bodyPr wrap="none" lIns="0" tIns="0" rIns="0" bIns="0" rtlCol="0" anchor="ctr"/>
           <a:lstStyle/>
           <a:p>
             <a:pPr algn="ctr"/>
@@ -6441,7 +6755,7 @@
           <a:noFill/>
         </p:spPr>
         <p:txBody>
-          <a:bodyPr wrap="square" anchor="t" lIns="0" rIns="0" tIns="0" bIns="0">
+          <a:bodyPr wrap="square" lIns="0" tIns="0" rIns="0" bIns="0" anchor="t">
             <a:spAutoFit/>
           </a:bodyPr>
           <a:lstStyle/>
@@ -6480,7 +6794,7 @@
           <a:noFill/>
         </p:spPr>
         <p:txBody>
-          <a:bodyPr wrap="square" anchor="t" lIns="0" rIns="0" tIns="0" bIns="0">
+          <a:bodyPr wrap="square" lIns="0" tIns="0" rIns="0" bIns="0" anchor="t">
             <a:spAutoFit/>
           </a:bodyPr>
           <a:lstStyle/>
@@ -6545,6 +6859,7 @@
           <a:lstStyle/>
           <a:p>
             <a:pPr algn="ctr"/>
+            <a:endParaRPr/>
           </a:p>
         </p:txBody>
       </p:sp>
@@ -6565,7 +6880,7 @@
           <a:noFill/>
         </p:spPr>
         <p:txBody>
-          <a:bodyPr wrap="square" anchor="ctr" lIns="0" rIns="0" tIns="0" bIns="0">
+          <a:bodyPr wrap="square" lIns="0" tIns="0" rIns="0" bIns="0" anchor="ctr">
             <a:spAutoFit/>
           </a:bodyPr>
           <a:lstStyle/>
@@ -6604,7 +6919,7 @@
           <a:noFill/>
         </p:spPr>
         <p:txBody>
-          <a:bodyPr wrap="square" anchor="t" lIns="0" rIns="0" tIns="0" bIns="0">
+          <a:bodyPr wrap="square" lIns="0" tIns="0" rIns="0" bIns="0" anchor="t">
             <a:spAutoFit/>
           </a:bodyPr>
           <a:lstStyle/>
@@ -6635,7 +6950,7 @@
 </file>
 
 <file path=ppt/slides/slide4.xml><?xml version="1.0" encoding="utf-8"?>
-<p:sld xmlns:a="http://schemas.openxmlformats.org/drawingml/2006/main" xmlns:p="http://schemas.openxmlformats.org/presentationml/2006/main" xmlns:r="http://schemas.openxmlformats.org/officeDocument/2006/relationships">
+<p:sld xmlns:a="http://schemas.openxmlformats.org/drawingml/2006/main" xmlns:r="http://schemas.openxmlformats.org/officeDocument/2006/relationships" xmlns:p="http://schemas.openxmlformats.org/presentationml/2006/main">
   <p:cSld>
     <p:bg>
       <p:bgPr>
@@ -6651,7 +6966,14 @@
         <p:cNvGrpSpPr/>
         <p:nvPr/>
       </p:nvGrpSpPr>
-      <p:grpSpPr/>
+      <p:grpSpPr>
+        <a:xfrm>
+          <a:off x="0" y="0"/>
+          <a:ext cx="0" cy="0"/>
+          <a:chOff x="0" y="0"/>
+          <a:chExt cx="0" cy="0"/>
+        </a:xfrm>
+      </p:grpSpPr>
       <p:sp>
         <p:nvSpPr>
           <p:cNvPr id="2" name="TextBox 1"/>
@@ -6669,7 +6991,7 @@
           <a:noFill/>
         </p:spPr>
         <p:txBody>
-          <a:bodyPr wrap="square" anchor="t" lIns="0" rIns="0" tIns="0" bIns="0">
+          <a:bodyPr wrap="square" lIns="0" tIns="0" rIns="0" bIns="0" anchor="t">
             <a:spAutoFit/>
           </a:bodyPr>
           <a:lstStyle/>
@@ -6708,7 +7030,7 @@
           <a:noFill/>
         </p:spPr>
         <p:txBody>
-          <a:bodyPr wrap="square" anchor="t" lIns="0" rIns="0" tIns="0" bIns="0">
+          <a:bodyPr wrap="square" lIns="0" tIns="0" rIns="0" bIns="0" anchor="t">
             <a:spAutoFit/>
           </a:bodyPr>
           <a:lstStyle/>
@@ -6736,7 +7058,13 @@
           <p:cNvGraphicFramePr>
             <a:graphicFrameLocks noGrp="1"/>
           </p:cNvGraphicFramePr>
-          <p:nvPr/>
+          <p:nvPr>
+            <p:extLst>
+              <p:ext uri="{D42A27DB-BD31-4B8C-83A1-F6EECF244321}">
+                <p14:modId xmlns:p14="http://schemas.microsoft.com/office/powerpoint/2010/main" val="1429068785"/>
+              </p:ext>
+            </p:extLst>
+          </p:nvPr>
         </p:nvGraphicFramePr>
         <p:xfrm>
           <a:off x="457200" y="1600200"/>
@@ -6744,7 +7072,7 @@
         </p:xfrm>
         <a:graphic>
           <a:graphicData uri="http://schemas.openxmlformats.org/drawingml/2006/chart">
-            <c:chart xmlns:c="http://schemas.openxmlformats.org/drawingml/2006/chart" r:id="rId2"/>
+            <c:chart xmlns:c="http://schemas.openxmlformats.org/drawingml/2006/chart" xmlns:r="http://schemas.openxmlformats.org/officeDocument/2006/relationships" r:id="rId2"/>
           </a:graphicData>
         </a:graphic>
       </p:graphicFrame>
@@ -6765,7 +7093,7 @@
           <a:noFill/>
         </p:spPr>
         <p:txBody>
-          <a:bodyPr wrap="square" anchor="t" lIns="0" rIns="0" tIns="0" bIns="0">
+          <a:bodyPr wrap="square" lIns="0" tIns="0" rIns="0" bIns="0" anchor="t">
             <a:spAutoFit/>
           </a:bodyPr>
           <a:lstStyle/>
@@ -6796,7 +7124,7 @@
         <p:spPr>
           <a:xfrm>
             <a:off x="8366760" y="2057400"/>
-            <a:ext cx="3291840" cy="4023360"/>
+            <a:ext cx="3291840" cy="2326984"/>
           </a:xfrm>
           <a:prstGeom prst="rect">
             <a:avLst/>
@@ -6804,7 +7132,7 @@
           <a:noFill/>
         </p:spPr>
         <p:txBody>
-          <a:bodyPr wrap="square" lIns="0" rIns="0" tIns="0" bIns="0">
+          <a:bodyPr wrap="square" lIns="0" tIns="0" rIns="0" bIns="0">
             <a:spAutoFit/>
           </a:bodyPr>
           <a:lstStyle/>
@@ -6823,13 +7151,40 @@
               <a:buChar char="•"/>
             </a:pPr>
             <a:r>
-              <a:rPr sz="1050">
+              <a:rPr sz="1050" dirty="0">
                 <a:solidFill>
                   <a:srgbClr val="1B2A4A"/>
                 </a:solidFill>
                 <a:latin typeface="Calibri"/>
               </a:rPr>
-              <a:t>Llama-4-Maverick with the instructional prompt removes the most PII (85.0%) while keeping clinical content nearly intact (99.5%)</a:t>
+              <a:t>Llama-4-Maverick with the instructional prompt removes the most </a:t>
+            </a:r>
+            <a:r>
+              <a:rPr lang="en-US" sz="1050" dirty="0" err="1">
+                <a:solidFill>
+                  <a:srgbClr val="1B2A4A"/>
+                </a:solidFill>
+                <a:latin typeface="Calibri"/>
+              </a:rPr>
+              <a:t>e</a:t>
+            </a:r>
+            <a:r>
+              <a:rPr sz="1050" dirty="0" err="1">
+                <a:solidFill>
+                  <a:srgbClr val="1B2A4A"/>
+                </a:solidFill>
+                <a:latin typeface="Calibri"/>
+              </a:rPr>
+              <a:t>PII</a:t>
+            </a:r>
+            <a:r>
+              <a:rPr sz="1050" dirty="0">
+                <a:solidFill>
+                  <a:srgbClr val="1B2A4A"/>
+                </a:solidFill>
+                <a:latin typeface="Calibri"/>
+              </a:rPr>
+              <a:t> (85.0%) while keeping clinical content nearly intact (99.5%)</a:t>
             </a:r>
           </a:p>
           <a:p>
@@ -6847,7 +7202,7 @@
               <a:buChar char="•"/>
             </a:pPr>
             <a:r>
-              <a:rPr sz="1050">
+              <a:rPr sz="1050" dirty="0">
                 <a:solidFill>
                   <a:srgbClr val="1B2A4A"/>
                 </a:solidFill>
@@ -6871,7 +7226,7 @@
               <a:buChar char="•"/>
             </a:pPr>
             <a:r>
-              <a:rPr sz="1050">
+              <a:rPr sz="1050" dirty="0">
                 <a:solidFill>
                   <a:srgbClr val="1B2A4A"/>
                 </a:solidFill>
@@ -6895,7 +7250,7 @@
               <a:buChar char="•"/>
             </a:pPr>
             <a:r>
-              <a:rPr sz="1050">
+              <a:rPr sz="1050" dirty="0">
                 <a:solidFill>
                   <a:srgbClr val="1B2A4A"/>
                 </a:solidFill>
@@ -6923,7 +7278,7 @@
           <a:noFill/>
         </p:spPr>
         <p:txBody>
-          <a:bodyPr wrap="square" anchor="t" lIns="0" rIns="0" tIns="0" bIns="0">
+          <a:bodyPr wrap="square" lIns="0" tIns="0" rIns="0" bIns="0" anchor="t">
             <a:spAutoFit/>
           </a:bodyPr>
           <a:lstStyle/>
@@ -6954,7 +7309,7 @@
 </file>
 
 <file path=ppt/slides/slide5.xml><?xml version="1.0" encoding="utf-8"?>
-<p:sld xmlns:a="http://schemas.openxmlformats.org/drawingml/2006/main" xmlns:p="http://schemas.openxmlformats.org/presentationml/2006/main" xmlns:r="http://schemas.openxmlformats.org/officeDocument/2006/relationships">
+<p:sld xmlns:a="http://schemas.openxmlformats.org/drawingml/2006/main" xmlns:r="http://schemas.openxmlformats.org/officeDocument/2006/relationships" xmlns:p="http://schemas.openxmlformats.org/presentationml/2006/main">
   <p:cSld>
     <p:bg>
       <p:bgPr>
@@ -6970,7 +7325,14 @@
         <p:cNvGrpSpPr/>
         <p:nvPr/>
       </p:nvGrpSpPr>
-      <p:grpSpPr/>
+      <p:grpSpPr>
+        <a:xfrm>
+          <a:off x="0" y="0"/>
+          <a:ext cx="0" cy="0"/>
+          <a:chOff x="0" y="0"/>
+          <a:chExt cx="0" cy="0"/>
+        </a:xfrm>
+      </p:grpSpPr>
       <p:sp>
         <p:nvSpPr>
           <p:cNvPr id="2" name="TextBox 1"/>
@@ -6988,7 +7350,7 @@
           <a:noFill/>
         </p:spPr>
         <p:txBody>
-          <a:bodyPr wrap="square" anchor="t" lIns="0" rIns="0" tIns="0" bIns="0">
+          <a:bodyPr wrap="square" lIns="0" tIns="0" rIns="0" bIns="0" anchor="t">
             <a:spAutoFit/>
           </a:bodyPr>
           <a:lstStyle/>
@@ -7027,7 +7389,7 @@
           <a:noFill/>
         </p:spPr>
         <p:txBody>
-          <a:bodyPr wrap="square" anchor="t" lIns="0" rIns="0" tIns="0" bIns="0">
+          <a:bodyPr wrap="square" lIns="0" tIns="0" rIns="0" bIns="0" anchor="t">
             <a:spAutoFit/>
           </a:bodyPr>
           <a:lstStyle/>
@@ -7063,7 +7425,7 @@
         </p:xfrm>
         <a:graphic>
           <a:graphicData uri="http://schemas.openxmlformats.org/drawingml/2006/chart">
-            <c:chart xmlns:c="http://schemas.openxmlformats.org/drawingml/2006/chart" r:id="rId2"/>
+            <c:chart xmlns:c="http://schemas.openxmlformats.org/drawingml/2006/chart" xmlns:r="http://schemas.openxmlformats.org/officeDocument/2006/relationships" r:id="rId2"/>
           </a:graphicData>
         </a:graphic>
       </p:graphicFrame>
@@ -7084,7 +7446,7 @@
           <a:noFill/>
         </p:spPr>
         <p:txBody>
-          <a:bodyPr wrap="square" anchor="t" lIns="0" rIns="0" tIns="0" bIns="0">
+          <a:bodyPr wrap="square" lIns="0" tIns="0" rIns="0" bIns="0" anchor="t">
             <a:spAutoFit/>
           </a:bodyPr>
           <a:lstStyle/>
@@ -7123,7 +7485,7 @@
           <a:noFill/>
         </p:spPr>
         <p:txBody>
-          <a:bodyPr wrap="square" lIns="0" rIns="0" tIns="0" bIns="0">
+          <a:bodyPr wrap="square" lIns="0" tIns="0" rIns="0" bIns="0">
             <a:spAutoFit/>
           </a:bodyPr>
           <a:lstStyle/>
@@ -7266,7 +7628,7 @@
           <a:noFill/>
         </p:spPr>
         <p:txBody>
-          <a:bodyPr wrap="square" anchor="t" lIns="0" rIns="0" tIns="0" bIns="0">
+          <a:bodyPr wrap="square" lIns="0" tIns="0" rIns="0" bIns="0" anchor="t">
             <a:spAutoFit/>
           </a:bodyPr>
           <a:lstStyle/>
@@ -7297,7 +7659,7 @@
 </file>
 
 <file path=ppt/slides/slide6.xml><?xml version="1.0" encoding="utf-8"?>
-<p:sld xmlns:a="http://schemas.openxmlformats.org/drawingml/2006/main" xmlns:p="http://schemas.openxmlformats.org/presentationml/2006/main" xmlns:r="http://schemas.openxmlformats.org/officeDocument/2006/relationships">
+<p:sld xmlns:a="http://schemas.openxmlformats.org/drawingml/2006/main" xmlns:r="http://schemas.openxmlformats.org/officeDocument/2006/relationships" xmlns:p="http://schemas.openxmlformats.org/presentationml/2006/main">
   <p:cSld>
     <p:bg>
       <p:bgPr>
@@ -7313,7 +7675,14 @@
         <p:cNvGrpSpPr/>
         <p:nvPr/>
       </p:nvGrpSpPr>
-      <p:grpSpPr/>
+      <p:grpSpPr>
+        <a:xfrm>
+          <a:off x="0" y="0"/>
+          <a:ext cx="0" cy="0"/>
+          <a:chOff x="0" y="0"/>
+          <a:chExt cx="0" cy="0"/>
+        </a:xfrm>
+      </p:grpSpPr>
       <p:sp>
         <p:nvSpPr>
           <p:cNvPr id="2" name="TextBox 1"/>
@@ -7331,7 +7700,7 @@
           <a:noFill/>
         </p:spPr>
         <p:txBody>
-          <a:bodyPr wrap="square" anchor="t" lIns="0" rIns="0" tIns="0" bIns="0">
+          <a:bodyPr wrap="square" lIns="0" tIns="0" rIns="0" bIns="0" anchor="t">
             <a:spAutoFit/>
           </a:bodyPr>
           <a:lstStyle/>
@@ -7370,7 +7739,7 @@
           <a:noFill/>
         </p:spPr>
         <p:txBody>
-          <a:bodyPr wrap="square" anchor="t" lIns="0" rIns="0" tIns="0" bIns="0">
+          <a:bodyPr wrap="square" lIns="0" tIns="0" rIns="0" bIns="0" anchor="t">
             <a:spAutoFit/>
           </a:bodyPr>
           <a:lstStyle/>
@@ -7433,6 +7802,7 @@
           <a:lstStyle/>
           <a:p>
             <a:pPr algn="ctr"/>
+            <a:endParaRPr/>
           </a:p>
         </p:txBody>
       </p:sp>
@@ -7453,7 +7823,7 @@
           <a:noFill/>
         </p:spPr>
         <p:txBody>
-          <a:bodyPr wrap="square" anchor="ctr" lIns="0" rIns="0" tIns="0" bIns="0">
+          <a:bodyPr wrap="square" lIns="0" tIns="0" rIns="0" bIns="0" anchor="ctr">
             <a:spAutoFit/>
           </a:bodyPr>
           <a:lstStyle/>
@@ -7492,7 +7862,7 @@
           <a:noFill/>
         </p:spPr>
         <p:txBody>
-          <a:bodyPr wrap="square" anchor="ctr" lIns="0" rIns="0" tIns="0" bIns="0">
+          <a:bodyPr wrap="square" lIns="0" tIns="0" rIns="0" bIns="0" anchor="ctr">
             <a:spAutoFit/>
           </a:bodyPr>
           <a:lstStyle/>
@@ -7531,7 +7901,7 @@
           <a:noFill/>
         </p:spPr>
         <p:txBody>
-          <a:bodyPr wrap="square" anchor="ctr" lIns="0" rIns="0" tIns="0" bIns="0">
+          <a:bodyPr wrap="square" lIns="0" tIns="0" rIns="0" bIns="0" anchor="ctr">
             <a:spAutoFit/>
           </a:bodyPr>
           <a:lstStyle/>
@@ -7570,7 +7940,7 @@
           <a:noFill/>
         </p:spPr>
         <p:txBody>
-          <a:bodyPr wrap="square" anchor="ctr" lIns="0" rIns="0" tIns="0" bIns="0">
+          <a:bodyPr wrap="square" lIns="0" tIns="0" rIns="0" bIns="0" anchor="ctr">
             <a:spAutoFit/>
           </a:bodyPr>
           <a:lstStyle/>
@@ -7609,7 +7979,7 @@
           <a:noFill/>
         </p:spPr>
         <p:txBody>
-          <a:bodyPr wrap="square" anchor="ctr" lIns="0" rIns="0" tIns="0" bIns="0">
+          <a:bodyPr wrap="square" lIns="0" tIns="0" rIns="0" bIns="0" anchor="ctr">
             <a:spAutoFit/>
           </a:bodyPr>
           <a:lstStyle/>
@@ -7648,7 +8018,7 @@
           <a:noFill/>
         </p:spPr>
         <p:txBody>
-          <a:bodyPr wrap="square" anchor="ctr" lIns="0" rIns="0" tIns="0" bIns="0">
+          <a:bodyPr wrap="square" lIns="0" tIns="0" rIns="0" bIns="0" anchor="ctr">
             <a:spAutoFit/>
           </a:bodyPr>
           <a:lstStyle/>
@@ -7711,6 +8081,7 @@
           <a:lstStyle/>
           <a:p>
             <a:pPr algn="ctr"/>
+            <a:endParaRPr/>
           </a:p>
         </p:txBody>
       </p:sp>
@@ -7731,7 +8102,7 @@
           <a:noFill/>
         </p:spPr>
         <p:txBody>
-          <a:bodyPr wrap="square" anchor="ctr" lIns="0" rIns="0" tIns="0" bIns="0">
+          <a:bodyPr wrap="square" lIns="0" tIns="0" rIns="0" bIns="0" anchor="ctr">
             <a:spAutoFit/>
           </a:bodyPr>
           <a:lstStyle/>
@@ -7770,7 +8141,7 @@
           <a:noFill/>
         </p:spPr>
         <p:txBody>
-          <a:bodyPr wrap="square" anchor="ctr" lIns="0" rIns="0" tIns="0" bIns="0">
+          <a:bodyPr wrap="square" lIns="0" tIns="0" rIns="0" bIns="0" anchor="ctr">
             <a:spAutoFit/>
           </a:bodyPr>
           <a:lstStyle/>
@@ -7809,7 +8180,7 @@
           <a:noFill/>
         </p:spPr>
         <p:txBody>
-          <a:bodyPr wrap="square" anchor="ctr" lIns="0" rIns="0" tIns="0" bIns="0">
+          <a:bodyPr wrap="square" lIns="0" tIns="0" rIns="0" bIns="0" anchor="ctr">
             <a:spAutoFit/>
           </a:bodyPr>
           <a:lstStyle/>
@@ -7848,7 +8219,7 @@
           <a:noFill/>
         </p:spPr>
         <p:txBody>
-          <a:bodyPr wrap="square" anchor="ctr" lIns="0" rIns="0" tIns="0" bIns="0">
+          <a:bodyPr wrap="square" lIns="0" tIns="0" rIns="0" bIns="0" anchor="ctr">
             <a:spAutoFit/>
           </a:bodyPr>
           <a:lstStyle/>
@@ -7887,7 +8258,7 @@
           <a:noFill/>
         </p:spPr>
         <p:txBody>
-          <a:bodyPr wrap="square" anchor="ctr" lIns="0" rIns="0" tIns="0" bIns="0">
+          <a:bodyPr wrap="square" lIns="0" tIns="0" rIns="0" bIns="0" anchor="ctr">
             <a:spAutoFit/>
           </a:bodyPr>
           <a:lstStyle/>
@@ -7926,7 +8297,7 @@
           <a:noFill/>
         </p:spPr>
         <p:txBody>
-          <a:bodyPr wrap="square" anchor="ctr" lIns="0" rIns="0" tIns="0" bIns="0">
+          <a:bodyPr wrap="square" lIns="0" tIns="0" rIns="0" bIns="0" anchor="ctr">
             <a:spAutoFit/>
           </a:bodyPr>
           <a:lstStyle/>
@@ -7989,6 +8360,7 @@
           <a:lstStyle/>
           <a:p>
             <a:pPr algn="ctr"/>
+            <a:endParaRPr/>
           </a:p>
         </p:txBody>
       </p:sp>
@@ -8009,7 +8381,7 @@
           <a:noFill/>
         </p:spPr>
         <p:txBody>
-          <a:bodyPr wrap="square" anchor="ctr" lIns="0" rIns="0" tIns="0" bIns="0">
+          <a:bodyPr wrap="square" lIns="0" tIns="0" rIns="0" bIns="0" anchor="ctr">
             <a:spAutoFit/>
           </a:bodyPr>
           <a:lstStyle/>
@@ -8048,7 +8420,7 @@
           <a:noFill/>
         </p:spPr>
         <p:txBody>
-          <a:bodyPr wrap="square" anchor="ctr" lIns="0" rIns="0" tIns="0" bIns="0">
+          <a:bodyPr wrap="square" lIns="0" tIns="0" rIns="0" bIns="0" anchor="ctr">
             <a:spAutoFit/>
           </a:bodyPr>
           <a:lstStyle/>
@@ -8087,7 +8459,7 @@
           <a:noFill/>
         </p:spPr>
         <p:txBody>
-          <a:bodyPr wrap="square" anchor="ctr" lIns="0" rIns="0" tIns="0" bIns="0">
+          <a:bodyPr wrap="square" lIns="0" tIns="0" rIns="0" bIns="0" anchor="ctr">
             <a:spAutoFit/>
           </a:bodyPr>
           <a:lstStyle/>
@@ -8126,7 +8498,7 @@
           <a:noFill/>
         </p:spPr>
         <p:txBody>
-          <a:bodyPr wrap="square" anchor="ctr" lIns="0" rIns="0" tIns="0" bIns="0">
+          <a:bodyPr wrap="square" lIns="0" tIns="0" rIns="0" bIns="0" anchor="ctr">
             <a:spAutoFit/>
           </a:bodyPr>
           <a:lstStyle/>
@@ -8165,7 +8537,7 @@
           <a:noFill/>
         </p:spPr>
         <p:txBody>
-          <a:bodyPr wrap="square" anchor="ctr" lIns="0" rIns="0" tIns="0" bIns="0">
+          <a:bodyPr wrap="square" lIns="0" tIns="0" rIns="0" bIns="0" anchor="ctr">
             <a:spAutoFit/>
           </a:bodyPr>
           <a:lstStyle/>
@@ -8204,7 +8576,7 @@
           <a:noFill/>
         </p:spPr>
         <p:txBody>
-          <a:bodyPr wrap="square" anchor="ctr" lIns="0" rIns="0" tIns="0" bIns="0">
+          <a:bodyPr wrap="square" lIns="0" tIns="0" rIns="0" bIns="0" anchor="ctr">
             <a:spAutoFit/>
           </a:bodyPr>
           <a:lstStyle/>
@@ -8267,6 +8639,7 @@
           <a:lstStyle/>
           <a:p>
             <a:pPr algn="ctr"/>
+            <a:endParaRPr/>
           </a:p>
         </p:txBody>
       </p:sp>
@@ -8287,7 +8660,7 @@
           <a:noFill/>
         </p:spPr>
         <p:txBody>
-          <a:bodyPr wrap="square" anchor="ctr" lIns="0" rIns="0" tIns="0" bIns="0">
+          <a:bodyPr wrap="square" lIns="0" tIns="0" rIns="0" bIns="0" anchor="ctr">
             <a:spAutoFit/>
           </a:bodyPr>
           <a:lstStyle/>
@@ -8326,7 +8699,7 @@
           <a:noFill/>
         </p:spPr>
         <p:txBody>
-          <a:bodyPr wrap="square" anchor="ctr" lIns="0" rIns="0" tIns="0" bIns="0">
+          <a:bodyPr wrap="square" lIns="0" tIns="0" rIns="0" bIns="0" anchor="ctr">
             <a:spAutoFit/>
           </a:bodyPr>
           <a:lstStyle/>
@@ -8365,7 +8738,7 @@
           <a:noFill/>
         </p:spPr>
         <p:txBody>
-          <a:bodyPr wrap="square" anchor="ctr" lIns="0" rIns="0" tIns="0" bIns="0">
+          <a:bodyPr wrap="square" lIns="0" tIns="0" rIns="0" bIns="0" anchor="ctr">
             <a:spAutoFit/>
           </a:bodyPr>
           <a:lstStyle/>
@@ -8404,7 +8777,7 @@
           <a:noFill/>
         </p:spPr>
         <p:txBody>
-          <a:bodyPr wrap="square" anchor="ctr" lIns="0" rIns="0" tIns="0" bIns="0">
+          <a:bodyPr wrap="square" lIns="0" tIns="0" rIns="0" bIns="0" anchor="ctr">
             <a:spAutoFit/>
           </a:bodyPr>
           <a:lstStyle/>
@@ -8443,7 +8816,7 @@
           <a:noFill/>
         </p:spPr>
         <p:txBody>
-          <a:bodyPr wrap="square" anchor="ctr" lIns="0" rIns="0" tIns="0" bIns="0">
+          <a:bodyPr wrap="square" lIns="0" tIns="0" rIns="0" bIns="0" anchor="ctr">
             <a:spAutoFit/>
           </a:bodyPr>
           <a:lstStyle/>
@@ -8482,7 +8855,7 @@
           <a:noFill/>
         </p:spPr>
         <p:txBody>
-          <a:bodyPr wrap="square" anchor="ctr" lIns="0" rIns="0" tIns="0" bIns="0">
+          <a:bodyPr wrap="square" lIns="0" tIns="0" rIns="0" bIns="0" anchor="ctr">
             <a:spAutoFit/>
           </a:bodyPr>
           <a:lstStyle/>
@@ -8547,6 +8920,7 @@
           <a:lstStyle/>
           <a:p>
             <a:pPr algn="ctr"/>
+            <a:endParaRPr/>
           </a:p>
         </p:txBody>
       </p:sp>
@@ -8567,7 +8941,7 @@
           <a:noFill/>
         </p:spPr>
         <p:txBody>
-          <a:bodyPr wrap="square" anchor="t" lIns="0" rIns="0" tIns="0" bIns="0">
+          <a:bodyPr wrap="square" lIns="0" tIns="0" rIns="0" bIns="0" anchor="t">
             <a:spAutoFit/>
           </a:bodyPr>
           <a:lstStyle/>
@@ -8606,7 +8980,7 @@
           <a:noFill/>
         </p:spPr>
         <p:txBody>
-          <a:bodyPr wrap="square" lIns="0" rIns="0" tIns="0" bIns="0">
+          <a:bodyPr wrap="square" lIns="0" tIns="0" rIns="0" bIns="0">
             <a:spAutoFit/>
           </a:bodyPr>
           <a:lstStyle/>
@@ -8701,7 +9075,7 @@
           <a:noFill/>
         </p:spPr>
         <p:txBody>
-          <a:bodyPr wrap="square" anchor="t" lIns="0" rIns="0" tIns="0" bIns="0">
+          <a:bodyPr wrap="square" lIns="0" tIns="0" rIns="0" bIns="0" anchor="t">
             <a:spAutoFit/>
           </a:bodyPr>
           <a:lstStyle/>
@@ -8732,7 +9106,7 @@
 </file>
 
 <file path=ppt/slides/slide7.xml><?xml version="1.0" encoding="utf-8"?>
-<p:sld xmlns:a="http://schemas.openxmlformats.org/drawingml/2006/main" xmlns:p="http://schemas.openxmlformats.org/presentationml/2006/main" xmlns:r="http://schemas.openxmlformats.org/officeDocument/2006/relationships">
+<p:sld xmlns:a="http://schemas.openxmlformats.org/drawingml/2006/main" xmlns:r="http://schemas.openxmlformats.org/officeDocument/2006/relationships" xmlns:p="http://schemas.openxmlformats.org/presentationml/2006/main">
   <p:cSld>
     <p:bg>
       <p:bgPr>
@@ -8748,7 +9122,14 @@
         <p:cNvGrpSpPr/>
         <p:nvPr/>
       </p:nvGrpSpPr>
-      <p:grpSpPr/>
+      <p:grpSpPr>
+        <a:xfrm>
+          <a:off x="0" y="0"/>
+          <a:ext cx="0" cy="0"/>
+          <a:chOff x="0" y="0"/>
+          <a:chExt cx="0" cy="0"/>
+        </a:xfrm>
+      </p:grpSpPr>
       <p:sp>
         <p:nvSpPr>
           <p:cNvPr id="2" name="TextBox 1"/>
@@ -8766,7 +9147,7 @@
           <a:noFill/>
         </p:spPr>
         <p:txBody>
-          <a:bodyPr wrap="square" anchor="t" lIns="0" rIns="0" tIns="0" bIns="0">
+          <a:bodyPr wrap="square" lIns="0" tIns="0" rIns="0" bIns="0" anchor="t">
             <a:spAutoFit/>
           </a:bodyPr>
           <a:lstStyle/>
@@ -8805,7 +9186,7 @@
           <a:noFill/>
         </p:spPr>
         <p:txBody>
-          <a:bodyPr wrap="square" anchor="t" lIns="0" rIns="0" tIns="0" bIns="0">
+          <a:bodyPr wrap="square" lIns="0" tIns="0" rIns="0" bIns="0" anchor="t">
             <a:spAutoFit/>
           </a:bodyPr>
           <a:lstStyle/>
@@ -8864,7 +9245,7 @@
           </a:fontRef>
         </p:style>
         <p:txBody>
-          <a:bodyPr rtlCol="0" anchor="ctr" wrap="none" lIns="0" rIns="0" tIns="0" bIns="0"/>
+          <a:bodyPr wrap="none" lIns="0" tIns="0" rIns="0" bIns="0" rtlCol="0" anchor="ctr"/>
           <a:lstStyle/>
           <a:p>
             <a:pPr algn="ctr"/>
@@ -8897,7 +9278,7 @@
           <a:noFill/>
         </p:spPr>
         <p:txBody>
-          <a:bodyPr wrap="square" anchor="t" lIns="0" rIns="0" tIns="0" bIns="0">
+          <a:bodyPr wrap="square" lIns="0" tIns="0" rIns="0" bIns="0" anchor="t">
             <a:spAutoFit/>
           </a:bodyPr>
           <a:lstStyle/>
@@ -8936,7 +9317,7 @@
           <a:noFill/>
         </p:spPr>
         <p:txBody>
-          <a:bodyPr wrap="square" anchor="t" lIns="0" rIns="0" tIns="0" bIns="0">
+          <a:bodyPr wrap="square" lIns="0" tIns="0" rIns="0" bIns="0" anchor="t">
             <a:spAutoFit/>
           </a:bodyPr>
           <a:lstStyle/>
@@ -8995,7 +9376,7 @@
           </a:fontRef>
         </p:style>
         <p:txBody>
-          <a:bodyPr rtlCol="0" anchor="ctr" wrap="none" lIns="0" rIns="0" tIns="0" bIns="0"/>
+          <a:bodyPr wrap="none" lIns="0" tIns="0" rIns="0" bIns="0" rtlCol="0" anchor="ctr"/>
           <a:lstStyle/>
           <a:p>
             <a:pPr algn="ctr"/>
@@ -9028,7 +9409,7 @@
           <a:noFill/>
         </p:spPr>
         <p:txBody>
-          <a:bodyPr wrap="square" anchor="t" lIns="0" rIns="0" tIns="0" bIns="0">
+          <a:bodyPr wrap="square" lIns="0" tIns="0" rIns="0" bIns="0" anchor="t">
             <a:spAutoFit/>
           </a:bodyPr>
           <a:lstStyle/>
@@ -9067,7 +9448,7 @@
           <a:noFill/>
         </p:spPr>
         <p:txBody>
-          <a:bodyPr wrap="square" anchor="t" lIns="0" rIns="0" tIns="0" bIns="0">
+          <a:bodyPr wrap="square" lIns="0" tIns="0" rIns="0" bIns="0" anchor="t">
             <a:spAutoFit/>
           </a:bodyPr>
           <a:lstStyle/>
@@ -9126,7 +9507,7 @@
           </a:fontRef>
         </p:style>
         <p:txBody>
-          <a:bodyPr rtlCol="0" anchor="ctr" wrap="none" lIns="0" rIns="0" tIns="0" bIns="0"/>
+          <a:bodyPr wrap="none" lIns="0" tIns="0" rIns="0" bIns="0" rtlCol="0" anchor="ctr"/>
           <a:lstStyle/>
           <a:p>
             <a:pPr algn="ctr"/>
@@ -9159,7 +9540,7 @@
           <a:noFill/>
         </p:spPr>
         <p:txBody>
-          <a:bodyPr wrap="square" anchor="t" lIns="0" rIns="0" tIns="0" bIns="0">
+          <a:bodyPr wrap="square" lIns="0" tIns="0" rIns="0" bIns="0" anchor="t">
             <a:spAutoFit/>
           </a:bodyPr>
           <a:lstStyle/>
@@ -9198,7 +9579,7 @@
           <a:noFill/>
         </p:spPr>
         <p:txBody>
-          <a:bodyPr wrap="square" anchor="t" lIns="0" rIns="0" tIns="0" bIns="0">
+          <a:bodyPr wrap="square" lIns="0" tIns="0" rIns="0" bIns="0" anchor="t">
             <a:spAutoFit/>
           </a:bodyPr>
           <a:lstStyle/>
@@ -9257,7 +9638,7 @@
           </a:fontRef>
         </p:style>
         <p:txBody>
-          <a:bodyPr rtlCol="0" anchor="ctr" wrap="none" lIns="0" rIns="0" tIns="0" bIns="0"/>
+          <a:bodyPr wrap="none" lIns="0" tIns="0" rIns="0" bIns="0" rtlCol="0" anchor="ctr"/>
           <a:lstStyle/>
           <a:p>
             <a:pPr algn="ctr"/>
@@ -9290,7 +9671,7 @@
           <a:noFill/>
         </p:spPr>
         <p:txBody>
-          <a:bodyPr wrap="square" anchor="t" lIns="0" rIns="0" tIns="0" bIns="0">
+          <a:bodyPr wrap="square" lIns="0" tIns="0" rIns="0" bIns="0" anchor="t">
             <a:spAutoFit/>
           </a:bodyPr>
           <a:lstStyle/>
@@ -9329,7 +9710,7 @@
           <a:noFill/>
         </p:spPr>
         <p:txBody>
-          <a:bodyPr wrap="square" anchor="t" lIns="0" rIns="0" tIns="0" bIns="0">
+          <a:bodyPr wrap="square" lIns="0" tIns="0" rIns="0" bIns="0" anchor="t">
             <a:spAutoFit/>
           </a:bodyPr>
           <a:lstStyle/>
@@ -9388,7 +9769,7 @@
           </a:fontRef>
         </p:style>
         <p:txBody>
-          <a:bodyPr rtlCol="0" anchor="ctr" wrap="none" lIns="0" rIns="0" tIns="0" bIns="0"/>
+          <a:bodyPr wrap="none" lIns="0" tIns="0" rIns="0" bIns="0" rtlCol="0" anchor="ctr"/>
           <a:lstStyle/>
           <a:p>
             <a:pPr algn="ctr"/>
@@ -9421,7 +9802,7 @@
           <a:noFill/>
         </p:spPr>
         <p:txBody>
-          <a:bodyPr wrap="square" anchor="t" lIns="0" rIns="0" tIns="0" bIns="0">
+          <a:bodyPr wrap="square" lIns="0" tIns="0" rIns="0" bIns="0" anchor="t">
             <a:spAutoFit/>
           </a:bodyPr>
           <a:lstStyle/>
@@ -9460,7 +9841,7 @@
           <a:noFill/>
         </p:spPr>
         <p:txBody>
-          <a:bodyPr wrap="square" anchor="t" lIns="0" rIns="0" tIns="0" bIns="0">
+          <a:bodyPr wrap="square" lIns="0" tIns="0" rIns="0" bIns="0" anchor="t">
             <a:spAutoFit/>
           </a:bodyPr>
           <a:lstStyle/>
@@ -9499,7 +9880,7 @@
           <a:noFill/>
         </p:spPr>
         <p:txBody>
-          <a:bodyPr wrap="square" anchor="t" lIns="0" rIns="0" tIns="0" bIns="0">
+          <a:bodyPr wrap="square" lIns="0" tIns="0" rIns="0" bIns="0" anchor="t">
             <a:spAutoFit/>
           </a:bodyPr>
           <a:lstStyle/>
@@ -9530,7 +9911,7 @@
 </file>
 
 <file path=ppt/slides/slide8.xml><?xml version="1.0" encoding="utf-8"?>
-<p:sld xmlns:a="http://schemas.openxmlformats.org/drawingml/2006/main" xmlns:p="http://schemas.openxmlformats.org/presentationml/2006/main" xmlns:r="http://schemas.openxmlformats.org/officeDocument/2006/relationships">
+<p:sld xmlns:a="http://schemas.openxmlformats.org/drawingml/2006/main" xmlns:r="http://schemas.openxmlformats.org/officeDocument/2006/relationships" xmlns:p="http://schemas.openxmlformats.org/presentationml/2006/main">
   <p:cSld>
     <p:bg>
       <p:bgPr>
@@ -9546,7 +9927,14 @@
         <p:cNvGrpSpPr/>
         <p:nvPr/>
       </p:nvGrpSpPr>
-      <p:grpSpPr/>
+      <p:grpSpPr>
+        <a:xfrm>
+          <a:off x="0" y="0"/>
+          <a:ext cx="0" cy="0"/>
+          <a:chOff x="0" y="0"/>
+          <a:chExt cx="0" cy="0"/>
+        </a:xfrm>
+      </p:grpSpPr>
       <p:sp>
         <p:nvSpPr>
           <p:cNvPr id="2" name="TextBox 1"/>
@@ -9564,7 +9952,7 @@
           <a:noFill/>
         </p:spPr>
         <p:txBody>
-          <a:bodyPr wrap="square" anchor="t" lIns="0" rIns="0" tIns="0" bIns="0">
+          <a:bodyPr wrap="square" lIns="0" tIns="0" rIns="0" bIns="0" anchor="t">
             <a:spAutoFit/>
           </a:bodyPr>
           <a:lstStyle/>
@@ -9603,7 +9991,7 @@
           <a:noFill/>
         </p:spPr>
         <p:txBody>
-          <a:bodyPr wrap="square" anchor="t" lIns="0" rIns="0" tIns="0" bIns="0">
+          <a:bodyPr wrap="square" lIns="0" tIns="0" rIns="0" bIns="0" anchor="t">
             <a:spAutoFit/>
           </a:bodyPr>
           <a:lstStyle/>
@@ -9642,7 +10030,7 @@
           <a:noFill/>
         </p:spPr>
         <p:txBody>
-          <a:bodyPr wrap="square" anchor="t" lIns="0" rIns="0" tIns="0" bIns="0">
+          <a:bodyPr wrap="square" lIns="0" tIns="0" rIns="0" bIns="0" anchor="t">
             <a:spAutoFit/>
           </a:bodyPr>
           <a:lstStyle/>
@@ -9673,7 +10061,7 @@
         <p:spPr>
           <a:xfrm>
             <a:off x="548640" y="2011680"/>
-            <a:ext cx="5212080" cy="4206240"/>
+            <a:ext cx="5212080" cy="2398990"/>
           </a:xfrm>
           <a:prstGeom prst="rect">
             <a:avLst/>
@@ -9681,7 +10069,7 @@
           <a:noFill/>
         </p:spPr>
         <p:txBody>
-          <a:bodyPr wrap="square" lIns="0" rIns="0" tIns="0" bIns="0">
+          <a:bodyPr wrap="square" lIns="0" tIns="0" rIns="0" bIns="0">
             <a:spAutoFit/>
           </a:bodyPr>
           <a:lstStyle/>
@@ -9700,14 +10088,19 @@
               <a:buChar char="•"/>
             </a:pPr>
             <a:r>
-              <a:rPr sz="1200">
+              <a:rPr lang="en-US" sz="1200" dirty="0">
                 <a:solidFill>
                   <a:srgbClr val="CFDCEA"/>
                 </a:solidFill>
-                <a:latin typeface="Calibri"/>
-              </a:rPr>
-              <a:t>Rephrasing-based anonymization beats entity masking decisively: 99.5% clinical content preserved vs. 68.1% for NER, at comparable or better privacy</a:t>
-            </a:r>
+              </a:rPr>
+              <a:t>Rephrasing beats entity masking on both axes: 99.5% clinical content preserved vs. 68.1% for NER, while also removing more PII (85.0% vs. NER's 53.5% — the lowest of all 7 configurations)</a:t>
+            </a:r>
+            <a:endParaRPr sz="1200" dirty="0">
+              <a:solidFill>
+                <a:srgbClr val="CFDCEA"/>
+              </a:solidFill>
+              <a:latin typeface="Calibri"/>
+            </a:endParaRPr>
           </a:p>
           <a:p>
             <a:pPr marL="228600" indent="-228600">
@@ -9724,7 +10117,7 @@
               <a:buChar char="•"/>
             </a:pPr>
             <a:r>
-              <a:rPr sz="1200">
+              <a:rPr sz="1200" dirty="0">
                 <a:solidFill>
                   <a:srgbClr val="CFDCEA"/>
                 </a:solidFill>
@@ -9748,7 +10141,7 @@
               <a:buChar char="•"/>
             </a:pPr>
             <a:r>
-              <a:rPr sz="1200">
+              <a:rPr sz="1200" dirty="0">
                 <a:solidFill>
                   <a:srgbClr val="CFDCEA"/>
                 </a:solidFill>
@@ -9772,7 +10165,7 @@
               <a:buChar char="•"/>
             </a:pPr>
             <a:r>
-              <a:rPr sz="1200">
+              <a:rPr sz="1200" dirty="0">
                 <a:solidFill>
                   <a:srgbClr val="CFDCEA"/>
                 </a:solidFill>
@@ -9800,7 +10193,7 @@
           <a:noFill/>
         </p:spPr>
         <p:txBody>
-          <a:bodyPr wrap="square" anchor="t" lIns="0" rIns="0" tIns="0" bIns="0">
+          <a:bodyPr wrap="square" lIns="0" tIns="0" rIns="0" bIns="0" anchor="t">
             <a:spAutoFit/>
           </a:bodyPr>
           <a:lstStyle/>
@@ -9865,6 +10258,7 @@
           <a:lstStyle/>
           <a:p>
             <a:pPr algn="ctr"/>
+            <a:endParaRPr/>
           </a:p>
         </p:txBody>
       </p:sp>
@@ -9905,7 +10299,7 @@
           </a:fontRef>
         </p:style>
         <p:txBody>
-          <a:bodyPr rtlCol="0" anchor="ctr" wrap="none" lIns="0" rIns="0" tIns="0" bIns="0"/>
+          <a:bodyPr wrap="none" lIns="0" tIns="0" rIns="0" bIns="0" rtlCol="0" anchor="ctr"/>
           <a:lstStyle/>
           <a:p>
             <a:pPr algn="ctr"/>
@@ -9938,7 +10332,7 @@
           <a:noFill/>
         </p:spPr>
         <p:txBody>
-          <a:bodyPr wrap="square" anchor="ctr" lIns="0" rIns="0" tIns="0" bIns="0">
+          <a:bodyPr wrap="square" lIns="0" tIns="0" rIns="0" bIns="0" anchor="ctr">
             <a:spAutoFit/>
           </a:bodyPr>
           <a:lstStyle/>
@@ -10003,6 +10397,7 @@
           <a:lstStyle/>
           <a:p>
             <a:pPr algn="ctr"/>
+            <a:endParaRPr/>
           </a:p>
         </p:txBody>
       </p:sp>
@@ -10043,7 +10438,7 @@
           </a:fontRef>
         </p:style>
         <p:txBody>
-          <a:bodyPr rtlCol="0" anchor="ctr" wrap="none" lIns="0" rIns="0" tIns="0" bIns="0"/>
+          <a:bodyPr wrap="none" lIns="0" tIns="0" rIns="0" bIns="0" rtlCol="0" anchor="ctr"/>
           <a:lstStyle/>
           <a:p>
             <a:pPr algn="ctr"/>
@@ -10076,7 +10471,7 @@
           <a:noFill/>
         </p:spPr>
         <p:txBody>
-          <a:bodyPr wrap="square" anchor="ctr" lIns="0" rIns="0" tIns="0" bIns="0">
+          <a:bodyPr wrap="square" lIns="0" tIns="0" rIns="0" bIns="0" anchor="ctr">
             <a:spAutoFit/>
           </a:bodyPr>
           <a:lstStyle/>
@@ -10141,6 +10536,7 @@
           <a:lstStyle/>
           <a:p>
             <a:pPr algn="ctr"/>
+            <a:endParaRPr/>
           </a:p>
         </p:txBody>
       </p:sp>
@@ -10181,7 +10577,7 @@
           </a:fontRef>
         </p:style>
         <p:txBody>
-          <a:bodyPr rtlCol="0" anchor="ctr" wrap="none" lIns="0" rIns="0" tIns="0" bIns="0"/>
+          <a:bodyPr wrap="none" lIns="0" tIns="0" rIns="0" bIns="0" rtlCol="0" anchor="ctr"/>
           <a:lstStyle/>
           <a:p>
             <a:pPr algn="ctr"/>
@@ -10205,8 +10601,8 @@
         </p:nvSpPr>
         <p:spPr>
           <a:xfrm>
-            <a:off x="6995160" y="4297680"/>
-            <a:ext cx="4480560" cy="685800"/>
+            <a:off x="6995160" y="4552671"/>
+            <a:ext cx="4480560" cy="175817"/>
           </a:xfrm>
           <a:prstGeom prst="rect">
             <a:avLst/>
@@ -10214,7 +10610,7 @@
           <a:noFill/>
         </p:spPr>
         <p:txBody>
-          <a:bodyPr wrap="square" anchor="ctr" lIns="0" rIns="0" tIns="0" bIns="0">
+          <a:bodyPr wrap="square" lIns="0" tIns="0" rIns="0" bIns="0" anchor="ctr">
             <a:spAutoFit/>
           </a:bodyPr>
           <a:lstStyle/>
@@ -10225,14 +10621,47 @@
               </a:lnSpc>
             </a:pPr>
             <a:r>
-              <a:rPr sz="1100" b="0" i="0">
+              <a:rPr sz="1100" b="0" i="0" dirty="0">
                 <a:solidFill>
                   <a:srgbClr val="FFFFFF"/>
                 </a:solidFill>
                 <a:latin typeface="Calibri"/>
               </a:rPr>
-              <a:t>Run the LLM-judge on the full 878-patient set, not a 50-patient sample</a:t>
-            </a:r>
+              <a:t>Run the LLM-judge on the full 878-patient set, not </a:t>
+            </a:r>
+            <a:r>
+              <a:rPr lang="en-US" sz="1100" dirty="0">
+                <a:solidFill>
+                  <a:srgbClr val="FFFFFF"/>
+                </a:solidFill>
+                <a:latin typeface="Calibri"/>
+              </a:rPr>
+              <a:t>just </a:t>
+            </a:r>
+            <a:r>
+              <a:rPr sz="1100" b="0" i="0" dirty="0">
+                <a:solidFill>
+                  <a:srgbClr val="FFFFFF"/>
+                </a:solidFill>
+                <a:latin typeface="Calibri"/>
+              </a:rPr>
+              <a:t>sample</a:t>
+            </a:r>
+            <a:r>
+              <a:rPr lang="en-US" sz="1100" b="0" i="0" dirty="0">
+                <a:solidFill>
+                  <a:srgbClr val="FFFFFF"/>
+                </a:solidFill>
+                <a:latin typeface="Calibri"/>
+              </a:rPr>
+              <a:t>s</a:t>
+            </a:r>
+            <a:endParaRPr sz="1100" b="0" i="0" dirty="0">
+              <a:solidFill>
+                <a:srgbClr val="FFFFFF"/>
+              </a:solidFill>
+              <a:latin typeface="Calibri"/>
+            </a:endParaRPr>
           </a:p>
         </p:txBody>
       </p:sp>
@@ -10279,6 +10708,7 @@
           <a:lstStyle/>
           <a:p>
             <a:pPr algn="ctr"/>
+            <a:endParaRPr/>
           </a:p>
         </p:txBody>
       </p:sp>
@@ -10319,7 +10749,7 @@
           </a:fontRef>
         </p:style>
         <p:txBody>
-          <a:bodyPr rtlCol="0" anchor="ctr" wrap="none" lIns="0" rIns="0" tIns="0" bIns="0"/>
+          <a:bodyPr wrap="none" lIns="0" tIns="0" rIns="0" bIns="0" rtlCol="0" anchor="ctr"/>
           <a:lstStyle/>
           <a:p>
             <a:pPr algn="ctr"/>
@@ -10352,7 +10782,7 @@
           <a:noFill/>
         </p:spPr>
         <p:txBody>
-          <a:bodyPr wrap="square" anchor="ctr" lIns="0" rIns="0" tIns="0" bIns="0">
+          <a:bodyPr wrap="square" lIns="0" tIns="0" rIns="0" bIns="0" anchor="ctr">
             <a:spAutoFit/>
           </a:bodyPr>
           <a:lstStyle/>
@@ -10391,7 +10821,7 @@
           <a:noFill/>
         </p:spPr>
         <p:txBody>
-          <a:bodyPr wrap="square" anchor="t" lIns="0" rIns="0" tIns="0" bIns="0">
+          <a:bodyPr wrap="square" lIns="0" tIns="0" rIns="0" bIns="0" anchor="t">
             <a:spAutoFit/>
           </a:bodyPr>
           <a:lstStyle/>

</xml_diff>